<commit_message>
push diagrama cause effect corectata.
</commit_message>
<xml_diff>
--- a/Testarea sistemelor software – Testare unitară în Python.pptx
+++ b/Testarea sistemelor software – Testare unitară în Python.pptx
@@ -115,7 +115,18 @@
   </p:defaultTextStyle>
   <p:extLst>
     <p:ext uri="{EFAFB233-063F-42B5-8137-9DF3F51BA10A}">
-      <p15:sldGuideLst xmlns:p15="http://schemas.microsoft.com/office/powerpoint/2012/main" xmlns=""/>
+      <p15:sldGuideLst xmlns:p15="http://schemas.microsoft.com/office/powerpoint/2012/main">
+        <p15:guide id="1" orient="horz" pos="2160">
+          <p15:clr>
+            <a:srgbClr val="A4A3A4"/>
+          </p15:clr>
+        </p15:guide>
+        <p15:guide id="2" pos="3840">
+          <p15:clr>
+            <a:srgbClr val="A4A3A4"/>
+          </p15:clr>
+        </p15:guide>
+      </p15:sldGuideLst>
     </p:ext>
   </p:extLst>
 </p:presentation>
@@ -341,7 +352,7 @@
           <p:cNvPr id="8" name="Date Placeholder 7">
             <a:extLst>
               <a:ext uri="{FF2B5EF4-FFF2-40B4-BE49-F238E27FC236}">
-                <a16:creationId xmlns:a16="http://schemas.microsoft.com/office/drawing/2014/main" xmlns="" id="{7FA0ACE7-29A8-47D3-A7D9-257B711D8023}"/>
+                <a16:creationId xmlns:a16="http://schemas.microsoft.com/office/drawing/2014/main" id="{7FA0ACE7-29A8-47D3-A7D9-257B711D8023}"/>
               </a:ext>
             </a:extLst>
           </p:cNvPr>
@@ -359,7 +370,7 @@
           <a:p>
             <a:fld id="{ED291B17-9318-49DB-B28B-6E5994AE9581}" type="datetime1">
               <a:rPr lang="en-US" smtClean="0"/>
-              <a:t>5/16/2026</a:t>
+              <a:t>5/17/2026</a:t>
             </a:fld>
             <a:endParaRPr lang="en-US" dirty="0"/>
           </a:p>
@@ -370,7 +381,7 @@
           <p:cNvPr id="9" name="Footer Placeholder 8">
             <a:extLst>
               <a:ext uri="{FF2B5EF4-FFF2-40B4-BE49-F238E27FC236}">
-                <a16:creationId xmlns:a16="http://schemas.microsoft.com/office/drawing/2014/main" xmlns="" id="{DEC604B9-52E9-4810-8359-47206518D038}"/>
+                <a16:creationId xmlns:a16="http://schemas.microsoft.com/office/drawing/2014/main" id="{DEC604B9-52E9-4810-8359-47206518D038}"/>
               </a:ext>
             </a:extLst>
           </p:cNvPr>
@@ -395,7 +406,7 @@
           <p:cNvPr id="10" name="Slide Number Placeholder 9">
             <a:extLst>
               <a:ext uri="{FF2B5EF4-FFF2-40B4-BE49-F238E27FC236}">
-                <a16:creationId xmlns:a16="http://schemas.microsoft.com/office/drawing/2014/main" xmlns="" id="{5898A89F-CA25-400F-B05A-AECBF2517E4F}"/>
+                <a16:creationId xmlns:a16="http://schemas.microsoft.com/office/drawing/2014/main" id="{5898A89F-CA25-400F-B05A-AECBF2517E4F}"/>
               </a:ext>
             </a:extLst>
           </p:cNvPr>
@@ -562,7 +573,7 @@
           <a:p>
             <a:fld id="{2CED4963-E985-44C4-B8C4-FDD613B7C2F8}" type="datetime1">
               <a:rPr lang="en-US" smtClean="0"/>
-              <a:t>5/16/2026</a:t>
+              <a:t>5/17/2026</a:t>
             </a:fld>
             <a:endParaRPr lang="en-US" dirty="0"/>
           </a:p>
@@ -777,7 +788,7 @@
           <p:cNvPr id="8" name="Rectangle 7">
             <a:extLst>
               <a:ext uri="{FF2B5EF4-FFF2-40B4-BE49-F238E27FC236}">
-                <a16:creationId xmlns:a16="http://schemas.microsoft.com/office/drawing/2014/main" xmlns="" id="{F6423B97-A5D4-47B9-8861-73B3707A04CF}"/>
+                <a16:creationId xmlns:a16="http://schemas.microsoft.com/office/drawing/2014/main" id="{F6423B97-A5D4-47B9-8861-73B3707A04CF}"/>
               </a:ext>
             </a:extLst>
           </p:cNvPr>
@@ -820,7 +831,7 @@
           <p:cNvPr id="9" name="Rectangle 8">
             <a:extLst>
               <a:ext uri="{FF2B5EF4-FFF2-40B4-BE49-F238E27FC236}">
-                <a16:creationId xmlns:a16="http://schemas.microsoft.com/office/drawing/2014/main" xmlns="" id="{1AEC0421-37B4-4481-A10D-69FDF5EC7909}"/>
+                <a16:creationId xmlns:a16="http://schemas.microsoft.com/office/drawing/2014/main" id="{1AEC0421-37B4-4481-A10D-69FDF5EC7909}"/>
               </a:ext>
             </a:extLst>
           </p:cNvPr>
@@ -863,7 +874,7 @@
           <p:cNvPr id="10" name="Rectangle 9">
             <a:extLst>
               <a:ext uri="{FF2B5EF4-FFF2-40B4-BE49-F238E27FC236}">
-                <a16:creationId xmlns:a16="http://schemas.microsoft.com/office/drawing/2014/main" xmlns="" id="{5F7265B5-9F97-4F1E-99E9-74F7B7E62337}"/>
+                <a16:creationId xmlns:a16="http://schemas.microsoft.com/office/drawing/2014/main" id="{5F7265B5-9F97-4F1E-99E9-74F7B7E62337}"/>
               </a:ext>
             </a:extLst>
           </p:cNvPr>
@@ -906,7 +917,7 @@
           <p:cNvPr id="11" name="Date Placeholder 10">
             <a:extLst>
               <a:ext uri="{FF2B5EF4-FFF2-40B4-BE49-F238E27FC236}">
-                <a16:creationId xmlns:a16="http://schemas.microsoft.com/office/drawing/2014/main" xmlns="" id="{5C74A470-3BD3-4F33-80E5-67E6E87FCBE7}"/>
+                <a16:creationId xmlns:a16="http://schemas.microsoft.com/office/drawing/2014/main" id="{5C74A470-3BD3-4F33-80E5-67E6E87FCBE7}"/>
               </a:ext>
             </a:extLst>
           </p:cNvPr>
@@ -924,7 +935,7 @@
           <a:p>
             <a:fld id="{ED291B17-9318-49DB-B28B-6E5994AE9581}" type="datetime1">
               <a:rPr lang="en-US" smtClean="0"/>
-              <a:t>5/16/2026</a:t>
+              <a:t>5/17/2026</a:t>
             </a:fld>
             <a:endParaRPr lang="en-US" dirty="0"/>
           </a:p>
@@ -935,7 +946,7 @@
           <p:cNvPr id="12" name="Footer Placeholder 11">
             <a:extLst>
               <a:ext uri="{FF2B5EF4-FFF2-40B4-BE49-F238E27FC236}">
-                <a16:creationId xmlns:a16="http://schemas.microsoft.com/office/drawing/2014/main" xmlns="" id="{9A3A30BA-DB50-4D7D-BCDE-17D20FB354DF}"/>
+                <a16:creationId xmlns:a16="http://schemas.microsoft.com/office/drawing/2014/main" id="{9A3A30BA-DB50-4D7D-BCDE-17D20FB354DF}"/>
               </a:ext>
             </a:extLst>
           </p:cNvPr>
@@ -960,7 +971,7 @@
           <p:cNvPr id="13" name="Slide Number Placeholder 12">
             <a:extLst>
               <a:ext uri="{FF2B5EF4-FFF2-40B4-BE49-F238E27FC236}">
-                <a16:creationId xmlns:a16="http://schemas.microsoft.com/office/drawing/2014/main" xmlns="" id="{76FF9E58-C0B2-436B-A21C-DB45A00D6515}"/>
+                <a16:creationId xmlns:a16="http://schemas.microsoft.com/office/drawing/2014/main" id="{76FF9E58-C0B2-436B-A21C-DB45A00D6515}"/>
               </a:ext>
             </a:extLst>
           </p:cNvPr>
@@ -1104,7 +1115,7 @@
           <p:cNvPr id="8" name="Date Placeholder 7">
             <a:extLst>
               <a:ext uri="{FF2B5EF4-FFF2-40B4-BE49-F238E27FC236}">
-                <a16:creationId xmlns:a16="http://schemas.microsoft.com/office/drawing/2014/main" xmlns="" id="{770E6237-3456-439F-802D-3BA93FC7E3E5}"/>
+                <a16:creationId xmlns:a16="http://schemas.microsoft.com/office/drawing/2014/main" id="{770E6237-3456-439F-802D-3BA93FC7E3E5}"/>
               </a:ext>
             </a:extLst>
           </p:cNvPr>
@@ -1122,7 +1133,7 @@
           <a:p>
             <a:fld id="{78DD82B9-B8EE-4375-B6FF-88FA6ABB15D9}" type="datetime1">
               <a:rPr lang="en-US" smtClean="0"/>
-              <a:t>5/16/2026</a:t>
+              <a:t>5/17/2026</a:t>
             </a:fld>
             <a:endParaRPr lang="en-US" dirty="0"/>
           </a:p>
@@ -1133,7 +1144,7 @@
           <p:cNvPr id="9" name="Footer Placeholder 8">
             <a:extLst>
               <a:ext uri="{FF2B5EF4-FFF2-40B4-BE49-F238E27FC236}">
-                <a16:creationId xmlns:a16="http://schemas.microsoft.com/office/drawing/2014/main" xmlns="" id="{1356D3B5-6063-4A89-B88F-9D3043916FF8}"/>
+                <a16:creationId xmlns:a16="http://schemas.microsoft.com/office/drawing/2014/main" id="{1356D3B5-6063-4A89-B88F-9D3043916FF8}"/>
               </a:ext>
             </a:extLst>
           </p:cNvPr>
@@ -1158,7 +1169,7 @@
           <p:cNvPr id="10" name="Slide Number Placeholder 9">
             <a:extLst>
               <a:ext uri="{FF2B5EF4-FFF2-40B4-BE49-F238E27FC236}">
-                <a16:creationId xmlns:a16="http://schemas.microsoft.com/office/drawing/2014/main" xmlns="" id="{02B78BF7-69D3-4CE0-A631-50EFD41EEEB8}"/>
+                <a16:creationId xmlns:a16="http://schemas.microsoft.com/office/drawing/2014/main" id="{02B78BF7-69D3-4CE0-A631-50EFD41EEEB8}"/>
               </a:ext>
             </a:extLst>
           </p:cNvPr>
@@ -1416,7 +1427,7 @@
           <p:cNvPr id="7" name="Date Placeholder 6">
             <a:extLst>
               <a:ext uri="{FF2B5EF4-FFF2-40B4-BE49-F238E27FC236}">
-                <a16:creationId xmlns:a16="http://schemas.microsoft.com/office/drawing/2014/main" xmlns="" id="{61582016-5696-4A93-887F-BBB3B9002FE5}"/>
+                <a16:creationId xmlns:a16="http://schemas.microsoft.com/office/drawing/2014/main" id="{61582016-5696-4A93-887F-BBB3B9002FE5}"/>
               </a:ext>
             </a:extLst>
           </p:cNvPr>
@@ -1434,7 +1445,7 @@
           <a:p>
             <a:fld id="{B2497495-0637-405E-AE64-5CC7506D51F5}" type="datetime1">
               <a:rPr lang="en-US" smtClean="0"/>
-              <a:t>5/16/2026</a:t>
+              <a:t>5/17/2026</a:t>
             </a:fld>
             <a:endParaRPr lang="en-US" dirty="0"/>
           </a:p>
@@ -1445,7 +1456,7 @@
           <p:cNvPr id="9" name="Footer Placeholder 8">
             <a:extLst>
               <a:ext uri="{FF2B5EF4-FFF2-40B4-BE49-F238E27FC236}">
-                <a16:creationId xmlns:a16="http://schemas.microsoft.com/office/drawing/2014/main" xmlns="" id="{857CFCD5-1192-4E18-8A8F-29E153B44DA4}"/>
+                <a16:creationId xmlns:a16="http://schemas.microsoft.com/office/drawing/2014/main" id="{857CFCD5-1192-4E18-8A8F-29E153B44DA4}"/>
               </a:ext>
             </a:extLst>
           </p:cNvPr>
@@ -1470,7 +1481,7 @@
           <p:cNvPr id="10" name="Slide Number Placeholder 9">
             <a:extLst>
               <a:ext uri="{FF2B5EF4-FFF2-40B4-BE49-F238E27FC236}">
-                <a16:creationId xmlns:a16="http://schemas.microsoft.com/office/drawing/2014/main" xmlns="" id="{E39A109E-5018-4794-92B3-FD5E5BCD95E8}"/>
+                <a16:creationId xmlns:a16="http://schemas.microsoft.com/office/drawing/2014/main" id="{E39A109E-5018-4794-92B3-FD5E5BCD95E8}"/>
               </a:ext>
             </a:extLst>
           </p:cNvPr>
@@ -1687,7 +1698,7 @@
           <a:p>
             <a:fld id="{7BFFD690-9426-415D-8B65-26881E07B2D4}" type="datetime1">
               <a:rPr lang="en-US" smtClean="0"/>
-              <a:t>5/16/2026</a:t>
+              <a:t>5/17/2026</a:t>
             </a:fld>
             <a:endParaRPr lang="en-US" dirty="0"/>
           </a:p>
@@ -2109,7 +2120,7 @@
           <a:p>
             <a:fld id="{04C4989A-474C-40DE-95B9-011C28B71673}" type="datetime1">
               <a:rPr lang="en-US" smtClean="0"/>
-              <a:t>5/16/2026</a:t>
+              <a:t>5/17/2026</a:t>
             </a:fld>
             <a:endParaRPr lang="en-US" dirty="0"/>
           </a:p>
@@ -2232,7 +2243,7 @@
           <a:p>
             <a:fld id="{5DB4ED54-5B5E-4A04-93D3-5772E3CE3818}" type="datetime1">
               <a:rPr lang="en-US" smtClean="0"/>
-              <a:t>5/16/2026</a:t>
+              <a:t>5/17/2026</a:t>
             </a:fld>
             <a:endParaRPr lang="en-US" dirty="0"/>
           </a:p>
@@ -2327,7 +2338,7 @@
           <a:p>
             <a:fld id="{4EDE50D6-574B-40AF-946F-D52A04ADE379}" type="datetime1">
               <a:rPr lang="en-US" smtClean="0"/>
-              <a:t>5/16/2026</a:t>
+              <a:t>5/17/2026</a:t>
             </a:fld>
             <a:endParaRPr lang="en-US" dirty="0"/>
           </a:p>
@@ -2681,7 +2692,7 @@
           <p:cNvPr id="8" name="Date Placeholder 7">
             <a:extLst>
               <a:ext uri="{FF2B5EF4-FFF2-40B4-BE49-F238E27FC236}">
-                <a16:creationId xmlns:a16="http://schemas.microsoft.com/office/drawing/2014/main" xmlns="" id="{0B919CC2-2A65-446F-B538-9E6249035445}"/>
+                <a16:creationId xmlns:a16="http://schemas.microsoft.com/office/drawing/2014/main" id="{0B919CC2-2A65-446F-B538-9E6249035445}"/>
               </a:ext>
             </a:extLst>
           </p:cNvPr>
@@ -2704,7 +2715,7 @@
           <a:p>
             <a:fld id="{D82884F1-FFEA-405F-9602-3DCA865EDA4E}" type="datetime1">
               <a:rPr lang="en-US" smtClean="0"/>
-              <a:t>5/16/2026</a:t>
+              <a:t>5/17/2026</a:t>
             </a:fld>
             <a:endParaRPr lang="en-US" dirty="0"/>
           </a:p>
@@ -2715,7 +2726,7 @@
           <p:cNvPr id="10" name="Footer Placeholder 9">
             <a:extLst>
               <a:ext uri="{FF2B5EF4-FFF2-40B4-BE49-F238E27FC236}">
-                <a16:creationId xmlns:a16="http://schemas.microsoft.com/office/drawing/2014/main" xmlns="" id="{B72412AE-119E-4982-8B24-63365EFCA796}"/>
+                <a16:creationId xmlns:a16="http://schemas.microsoft.com/office/drawing/2014/main" id="{B72412AE-119E-4982-8B24-63365EFCA796}"/>
               </a:ext>
             </a:extLst>
           </p:cNvPr>
@@ -2745,7 +2756,7 @@
           <p:cNvPr id="11" name="Slide Number Placeholder 10">
             <a:extLst>
               <a:ext uri="{FF2B5EF4-FFF2-40B4-BE49-F238E27FC236}">
-                <a16:creationId xmlns:a16="http://schemas.microsoft.com/office/drawing/2014/main" xmlns="" id="{7FC4BB19-6AD1-45CF-9F99-00B109890FAB}"/>
+                <a16:creationId xmlns:a16="http://schemas.microsoft.com/office/drawing/2014/main" id="{7FC4BB19-6AD1-45CF-9F99-00B109890FAB}"/>
               </a:ext>
             </a:extLst>
           </p:cNvPr>
@@ -2997,7 +3008,7 @@
           <a:p>
             <a:fld id="{7E18DB4A-8810-4A10-AD5C-D5E2C667F5B3}" type="datetime1">
               <a:rPr lang="en-US" smtClean="0"/>
-              <a:t>5/16/2026</a:t>
+              <a:t>5/17/2026</a:t>
             </a:fld>
             <a:endParaRPr lang="en-US" dirty="0"/>
           </a:p>
@@ -3212,7 +3223,7 @@
           <a:p>
             <a:fld id="{ED291B17-9318-49DB-B28B-6E5994AE9581}" type="datetime1">
               <a:rPr lang="en-US" smtClean="0"/>
-              <a:t>5/16/2026</a:t>
+              <a:t>5/17/2026</a:t>
             </a:fld>
             <a:endParaRPr lang="en-US" dirty="0"/>
           </a:p>
@@ -3857,10 +3868,10 @@
           <p:cNvPr id="18" name="Rectangle 17">
             <a:extLst>
               <a:ext uri="{FF2B5EF4-FFF2-40B4-BE49-F238E27FC236}">
-                <a16:creationId xmlns:a16="http://schemas.microsoft.com/office/drawing/2014/main" xmlns="" id="{D6D7A0BC-0046-4CAA-8E7F-DCAFE511EA0E}"/>
+                <a16:creationId xmlns:a16="http://schemas.microsoft.com/office/drawing/2014/main" id="{D6D7A0BC-0046-4CAA-8E7F-DCAFE511EA0E}"/>
               </a:ext>
               <a:ext uri="{C183D7F6-B498-43B3-948B-1728B52AA6E4}">
-                <adec:decorative xmlns:adec="http://schemas.microsoft.com/office/drawing/2017/decorative" xmlns="" val="1"/>
+                <adec:decorative xmlns:adec="http://schemas.microsoft.com/office/drawing/2017/decorative" val="1"/>
               </a:ext>
             </a:extLst>
           </p:cNvPr>
@@ -3870,7 +3881,7 @@
           <p:nvPr>
             <p:extLst>
               <p:ext uri="{386F3935-93C4-4BCD-93E2-E3B085C9AB24}">
-                <p16:designElem xmlns:p16="http://schemas.microsoft.com/office/powerpoint/2015/main" xmlns="" val="1"/>
+                <p16:designElem xmlns:p16="http://schemas.microsoft.com/office/powerpoint/2015/main" val="1"/>
               </p:ext>
             </p:extLst>
           </p:nvPr>
@@ -3917,7 +3928,7 @@
           <p:cNvPr id="2" name="Title 1">
             <a:extLst>
               <a:ext uri="{FF2B5EF4-FFF2-40B4-BE49-F238E27FC236}">
-                <a16:creationId xmlns:a16="http://schemas.microsoft.com/office/drawing/2014/main" xmlns="" id="{1C21E816-31F5-48BB-BD02-D15F2F18B48A}"/>
+                <a16:creationId xmlns:a16="http://schemas.microsoft.com/office/drawing/2014/main" id="{1C21E816-31F5-48BB-BD02-D15F2F18B48A}"/>
               </a:ext>
             </a:extLst>
           </p:cNvPr>
@@ -3957,15 +3968,15 @@
               <a:t> software – </a:t>
             </a:r>
             <a:r>
-              <a:rPr lang="ro-RO" sz="2800" dirty="0" smtClean="0"/>
+              <a:rPr lang="ro-RO" sz="2800" dirty="0"/>
               <a:t>t1 - </a:t>
             </a:r>
             <a:r>
-              <a:rPr lang="en-US" sz="2800" dirty="0" err="1" smtClean="0"/>
+              <a:rPr lang="en-US" sz="2800" dirty="0" err="1"/>
               <a:t>Testare</a:t>
             </a:r>
             <a:r>
-              <a:rPr lang="en-US" sz="2800" dirty="0" smtClean="0"/>
+              <a:rPr lang="en-US" sz="2800" dirty="0"/>
               <a:t> </a:t>
             </a:r>
             <a:r>
@@ -3992,10 +4003,10 @@
           <p:cNvPr id="20" name="Rectangle 19">
             <a:extLst>
               <a:ext uri="{FF2B5EF4-FFF2-40B4-BE49-F238E27FC236}">
-                <a16:creationId xmlns:a16="http://schemas.microsoft.com/office/drawing/2014/main" xmlns="" id="{E7C6334F-6411-41EC-AD7D-179EDD8B58CB}"/>
+                <a16:creationId xmlns:a16="http://schemas.microsoft.com/office/drawing/2014/main" id="{E7C6334F-6411-41EC-AD7D-179EDD8B58CB}"/>
               </a:ext>
               <a:ext uri="{C183D7F6-B498-43B3-948B-1728B52AA6E4}">
-                <adec:decorative xmlns:adec="http://schemas.microsoft.com/office/drawing/2017/decorative" xmlns="" val="1"/>
+                <adec:decorative xmlns:adec="http://schemas.microsoft.com/office/drawing/2017/decorative" val="1"/>
               </a:ext>
             </a:extLst>
           </p:cNvPr>
@@ -4005,7 +4016,7 @@
           <p:nvPr>
             <p:extLst>
               <p:ext uri="{386F3935-93C4-4BCD-93E2-E3B085C9AB24}">
-                <p16:designElem xmlns:p16="http://schemas.microsoft.com/office/powerpoint/2015/main" xmlns="" val="1"/>
+                <p16:designElem xmlns:p16="http://schemas.microsoft.com/office/powerpoint/2015/main" val="1"/>
               </p:ext>
             </p:extLst>
           </p:nvPr>
@@ -4046,10 +4057,10 @@
           <p:cNvPr id="22" name="Rectangle 21">
             <a:extLst>
               <a:ext uri="{FF2B5EF4-FFF2-40B4-BE49-F238E27FC236}">
-                <a16:creationId xmlns:a16="http://schemas.microsoft.com/office/drawing/2014/main" xmlns="" id="{E6B02CEE-3AF8-4349-9B3E-8970E6DF62B3}"/>
+                <a16:creationId xmlns:a16="http://schemas.microsoft.com/office/drawing/2014/main" id="{E6B02CEE-3AF8-4349-9B3E-8970E6DF62B3}"/>
               </a:ext>
               <a:ext uri="{C183D7F6-B498-43B3-948B-1728B52AA6E4}">
-                <adec:decorative xmlns:adec="http://schemas.microsoft.com/office/drawing/2017/decorative" xmlns="" val="1"/>
+                <adec:decorative xmlns:adec="http://schemas.microsoft.com/office/drawing/2017/decorative" val="1"/>
               </a:ext>
             </a:extLst>
           </p:cNvPr>
@@ -4059,7 +4070,7 @@
           <p:nvPr>
             <p:extLst>
               <p:ext uri="{386F3935-93C4-4BCD-93E2-E3B085C9AB24}">
-                <p16:designElem xmlns:p16="http://schemas.microsoft.com/office/powerpoint/2015/main" xmlns="" val="1"/>
+                <p16:designElem xmlns:p16="http://schemas.microsoft.com/office/powerpoint/2015/main" val="1"/>
               </p:ext>
             </p:extLst>
           </p:nvPr>
@@ -4100,10 +4111,10 @@
           <p:cNvPr id="24" name="Rectangle 23">
             <a:extLst>
               <a:ext uri="{FF2B5EF4-FFF2-40B4-BE49-F238E27FC236}">
-                <a16:creationId xmlns:a16="http://schemas.microsoft.com/office/drawing/2014/main" xmlns="" id="{AAA01CF0-3FB5-44EB-B7DE-F2E86374C2FB}"/>
+                <a16:creationId xmlns:a16="http://schemas.microsoft.com/office/drawing/2014/main" id="{AAA01CF0-3FB5-44EB-B7DE-F2E86374C2FB}"/>
               </a:ext>
               <a:ext uri="{C183D7F6-B498-43B3-948B-1728B52AA6E4}">
-                <adec:decorative xmlns:adec="http://schemas.microsoft.com/office/drawing/2017/decorative" xmlns="" val="1"/>
+                <adec:decorative xmlns:adec="http://schemas.microsoft.com/office/drawing/2017/decorative" val="1"/>
               </a:ext>
             </a:extLst>
           </p:cNvPr>
@@ -4113,7 +4124,7 @@
           <p:nvPr>
             <p:extLst>
               <p:ext uri="{386F3935-93C4-4BCD-93E2-E3B085C9AB24}">
-                <p16:designElem xmlns:p16="http://schemas.microsoft.com/office/powerpoint/2015/main" xmlns="" val="1"/>
+                <p16:designElem xmlns:p16="http://schemas.microsoft.com/office/powerpoint/2015/main" val="1"/>
               </p:ext>
             </p:extLst>
           </p:nvPr>
@@ -4154,7 +4165,7 @@
           <p:cNvPr id="9" name="Subtitle 2">
             <a:extLst>
               <a:ext uri="{FF2B5EF4-FFF2-40B4-BE49-F238E27FC236}">
-                <a16:creationId xmlns:a16="http://schemas.microsoft.com/office/drawing/2014/main" xmlns="" id="{835D6E6B-3353-491C-A3C6-F278D6CED8B3}"/>
+                <a16:creationId xmlns:a16="http://schemas.microsoft.com/office/drawing/2014/main" id="{835D6E6B-3353-491C-A3C6-F278D6CED8B3}"/>
               </a:ext>
             </a:extLst>
           </p:cNvPr>
@@ -4397,7 +4408,7 @@
           </a:lstStyle>
           <a:p>
             <a:r>
-              <a:rPr lang="ro-RO" dirty="0" smtClean="0">
+              <a:rPr lang="ro-RO" dirty="0">
                 <a:latin typeface="Arial" pitchFamily="34" charset="0"/>
                 <a:cs typeface="Arial" pitchFamily="34" charset="0"/>
               </a:rPr>
@@ -4406,14 +4417,14 @@
           </a:p>
           <a:p>
             <a:r>
-              <a:rPr lang="ro-RO" dirty="0" smtClean="0">
+              <a:rPr lang="ro-RO" dirty="0">
                 <a:latin typeface="Arial" pitchFamily="34" charset="0"/>
                 <a:cs typeface="Arial" pitchFamily="34" charset="0"/>
               </a:rPr>
               <a:t>				     Nițe dan-alexandru (344)</a:t>
             </a:r>
             <a:br>
-              <a:rPr lang="ro-RO" dirty="0" smtClean="0">
+              <a:rPr lang="ro-RO" dirty="0">
                 <a:latin typeface="Arial" pitchFamily="34" charset="0"/>
                 <a:cs typeface="Arial" pitchFamily="34" charset="0"/>
               </a:rPr>
@@ -4430,7 +4441,7 @@
           <p:cNvPr id="10" name="Content Placeholder 3">
             <a:extLst>
               <a:ext uri="{FF2B5EF4-FFF2-40B4-BE49-F238E27FC236}">
-                <a16:creationId xmlns:a16="http://schemas.microsoft.com/office/drawing/2014/main" xmlns="" id="{1B021E2C-E4CD-07DF-0E58-8CBDCC812FD4}"/>
+                <a16:creationId xmlns:a16="http://schemas.microsoft.com/office/drawing/2014/main" id="{1B021E2C-E4CD-07DF-0E58-8CBDCC812FD4}"/>
               </a:ext>
             </a:extLst>
           </p:cNvPr>
@@ -4670,28 +4681,28 @@
           </a:lstStyle>
           <a:p>
             <a:r>
-              <a:rPr lang="ro-RO" sz="1600" b="1" dirty="0" smtClean="0">
+              <a:rPr lang="ro-RO" sz="1600" b="1" dirty="0">
                 <a:latin typeface="Arial" pitchFamily="34" charset="0"/>
                 <a:cs typeface="Arial" pitchFamily="34" charset="0"/>
               </a:rPr>
               <a:t>Clasa implementată: </a:t>
             </a:r>
             <a:r>
-              <a:rPr lang="en-US" sz="1600" i="1" dirty="0" err="1" smtClean="0">
+              <a:rPr lang="en-US" sz="1600" i="1" dirty="0" err="1">
                 <a:latin typeface="Arial" pitchFamily="34" charset="0"/>
                 <a:cs typeface="Arial" pitchFamily="34" charset="0"/>
               </a:rPr>
               <a:t>FitnessClassBooking</a:t>
             </a:r>
             <a:r>
-              <a:rPr lang="ro-RO" sz="1600" dirty="0" smtClean="0">
+              <a:rPr lang="ro-RO" sz="1600" dirty="0">
                 <a:latin typeface="Arial" pitchFamily="34" charset="0"/>
                 <a:cs typeface="Arial" pitchFamily="34" charset="0"/>
               </a:rPr>
               <a:t> </a:t>
             </a:r>
             <a:r>
-              <a:rPr lang="ro-RO" sz="1600" dirty="0" smtClean="0">
+              <a:rPr lang="ro-RO" sz="1600" dirty="0">
                 <a:latin typeface="Arial" pitchFamily="34" charset="0"/>
                 <a:cs typeface="Arial" pitchFamily="34" charset="0"/>
                 <a:sym typeface="Wingdings" pitchFamily="2" charset="2"/>
@@ -4699,7 +4710,7 @@
               <a:t></a:t>
             </a:r>
             <a:r>
-              <a:rPr lang="en-US" sz="1600" dirty="0" smtClean="0">
+              <a:rPr lang="en-US" sz="1600" dirty="0">
                 <a:latin typeface="Arial" pitchFamily="34" charset="0"/>
                 <a:cs typeface="Arial" pitchFamily="34" charset="0"/>
                 <a:sym typeface="Wingdings" pitchFamily="2" charset="2"/>
@@ -4714,42 +4725,42 @@
               </a:rPr>
               <a:t>modelează evaluarea unui pachet de ședințe pentru o clasă de fitness.</a:t>
             </a:r>
-            <a:endParaRPr lang="ro-RO" sz="1600" dirty="0" smtClean="0">
+            <a:endParaRPr lang="ro-RO" sz="1600" dirty="0">
               <a:latin typeface="Arial" pitchFamily="34" charset="0"/>
               <a:cs typeface="Arial" pitchFamily="34" charset="0"/>
             </a:endParaRPr>
           </a:p>
           <a:p>
             <a:r>
-              <a:rPr lang="ro-RO" sz="1600" b="1" dirty="0" smtClean="0">
+              <a:rPr lang="ro-RO" sz="1600" b="1" dirty="0">
                 <a:latin typeface="Arial" pitchFamily="34" charset="0"/>
                 <a:cs typeface="Arial" pitchFamily="34" charset="0"/>
               </a:rPr>
               <a:t>Metoda testată: </a:t>
             </a:r>
             <a:r>
-              <a:rPr lang="en-US" sz="1600" i="1" dirty="0" err="1" smtClean="0">
+              <a:rPr lang="en-US" sz="1600" i="1" dirty="0" err="1">
                 <a:latin typeface="Arial" pitchFamily="34" charset="0"/>
                 <a:cs typeface="Arial" pitchFamily="34" charset="0"/>
               </a:rPr>
               <a:t>evaluate_client_package</a:t>
             </a:r>
             <a:r>
-              <a:rPr lang="en-US" sz="1600" dirty="0" smtClean="0">
+              <a:rPr lang="en-US" sz="1600" dirty="0">
                 <a:latin typeface="Arial" pitchFamily="34" charset="0"/>
                 <a:cs typeface="Arial" pitchFamily="34" charset="0"/>
               </a:rPr>
               <a:t>(self,</a:t>
             </a:r>
             <a:r>
-              <a:rPr lang="ro-RO" sz="1600" dirty="0" smtClean="0">
+              <a:rPr lang="ro-RO" sz="1600" dirty="0">
                 <a:latin typeface="Arial" pitchFamily="34" charset="0"/>
                 <a:cs typeface="Arial" pitchFamily="34" charset="0"/>
               </a:rPr>
               <a:t> </a:t>
             </a:r>
             <a:r>
-              <a:rPr lang="en-US" sz="1600" dirty="0" err="1" smtClean="0">
+              <a:rPr lang="en-US" sz="1600" dirty="0" err="1">
                 <a:latin typeface="Arial" pitchFamily="34" charset="0"/>
                 <a:cs typeface="Arial" pitchFamily="34" charset="0"/>
               </a:rPr>
@@ -4770,21 +4781,21 @@
               <a:t>str</a:t>
             </a:r>
             <a:r>
-              <a:rPr lang="en-US" sz="1600" dirty="0" smtClean="0">
+              <a:rPr lang="en-US" sz="1600" dirty="0">
                 <a:latin typeface="Arial" pitchFamily="34" charset="0"/>
                 <a:cs typeface="Arial" pitchFamily="34" charset="0"/>
               </a:rPr>
               <a:t>],</a:t>
             </a:r>
             <a:r>
-              <a:rPr lang="ro-RO" sz="1600" dirty="0" smtClean="0">
+              <a:rPr lang="ro-RO" sz="1600" dirty="0">
                 <a:latin typeface="Arial" pitchFamily="34" charset="0"/>
                 <a:cs typeface="Arial" pitchFamily="34" charset="0"/>
               </a:rPr>
               <a:t> </a:t>
             </a:r>
             <a:r>
-              <a:rPr lang="en-US" sz="1600" dirty="0" err="1" smtClean="0">
+              <a:rPr lang="en-US" sz="1600" dirty="0" err="1">
                 <a:latin typeface="Arial" pitchFamily="34" charset="0"/>
                 <a:cs typeface="Arial" pitchFamily="34" charset="0"/>
               </a:rPr>
@@ -4805,21 +4816,21 @@
               <a:t>int</a:t>
             </a:r>
             <a:r>
-              <a:rPr lang="en-US" sz="1600" dirty="0" smtClean="0">
+              <a:rPr lang="en-US" sz="1600" dirty="0">
                 <a:latin typeface="Arial" pitchFamily="34" charset="0"/>
                 <a:cs typeface="Arial" pitchFamily="34" charset="0"/>
               </a:rPr>
               <a:t>,</a:t>
             </a:r>
             <a:r>
-              <a:rPr lang="ro-RO" sz="1600" dirty="0" smtClean="0">
+              <a:rPr lang="ro-RO" sz="1600" dirty="0">
                 <a:latin typeface="Arial" pitchFamily="34" charset="0"/>
                 <a:cs typeface="Arial" pitchFamily="34" charset="0"/>
               </a:rPr>
               <a:t> </a:t>
             </a:r>
             <a:r>
-              <a:rPr lang="en-US" sz="1600" dirty="0" err="1" smtClean="0">
+              <a:rPr lang="en-US" sz="1600" dirty="0" err="1">
                 <a:latin typeface="Arial" pitchFamily="34" charset="0"/>
                 <a:cs typeface="Arial" pitchFamily="34" charset="0"/>
               </a:rPr>
@@ -4833,20 +4844,20 @@
               <a:t>: </a:t>
             </a:r>
             <a:r>
-              <a:rPr lang="en-US" sz="1600" dirty="0" err="1" smtClean="0">
+              <a:rPr lang="en-US" sz="1600" dirty="0" err="1">
                 <a:latin typeface="Arial" pitchFamily="34" charset="0"/>
                 <a:cs typeface="Arial" pitchFamily="34" charset="0"/>
               </a:rPr>
               <a:t>bool</a:t>
             </a:r>
             <a:r>
-              <a:rPr lang="en-US" sz="1600" dirty="0" smtClean="0">
+              <a:rPr lang="en-US" sz="1600" dirty="0">
                 <a:latin typeface="Arial" pitchFamily="34" charset="0"/>
                 <a:cs typeface="Arial" pitchFamily="34" charset="0"/>
               </a:rPr>
               <a:t>)</a:t>
             </a:r>
-            <a:endParaRPr lang="ro-RO" sz="1600" dirty="0" smtClean="0">
+            <a:endParaRPr lang="ro-RO" sz="1600" dirty="0">
               <a:latin typeface="Arial" pitchFamily="34" charset="0"/>
               <a:cs typeface="Arial" pitchFamily="34" charset="0"/>
             </a:endParaRPr>
@@ -4860,14 +4871,14 @@
               <a:t>Framework </a:t>
             </a:r>
             <a:r>
-              <a:rPr lang="en-US" sz="1600" b="1" dirty="0" err="1" smtClean="0">
+              <a:rPr lang="en-US" sz="1600" b="1" dirty="0" err="1">
                 <a:latin typeface="Arial" pitchFamily="34" charset="0"/>
                 <a:cs typeface="Arial" pitchFamily="34" charset="0"/>
               </a:rPr>
               <a:t>testare</a:t>
             </a:r>
             <a:r>
-              <a:rPr lang="ro-RO" sz="1600" b="1" dirty="0" smtClean="0">
+              <a:rPr lang="ro-RO" sz="1600" b="1" dirty="0">
                 <a:latin typeface="Arial" pitchFamily="34" charset="0"/>
                 <a:cs typeface="Arial" pitchFamily="34" charset="0"/>
               </a:rPr>
@@ -4885,37 +4896,30 @@
                 <a:latin typeface="Arial" pitchFamily="34" charset="0"/>
                 <a:cs typeface="Arial" pitchFamily="34" charset="0"/>
               </a:rPr>
-              <a:t> </a:t>
-            </a:r>
-            <a:r>
-              <a:rPr lang="en-US" sz="1600" dirty="0" smtClean="0">
-                <a:latin typeface="Arial" pitchFamily="34" charset="0"/>
-                <a:cs typeface="Arial" pitchFamily="34" charset="0"/>
-              </a:rPr>
-              <a:t>9.0.3</a:t>
-            </a:r>
-            <a:endParaRPr lang="ro-RO" sz="1600" dirty="0" smtClean="0">
+              <a:t> 9.0.3</a:t>
+            </a:r>
+            <a:endParaRPr lang="ro-RO" sz="1600" dirty="0">
               <a:latin typeface="Arial" pitchFamily="34" charset="0"/>
               <a:cs typeface="Arial" pitchFamily="34" charset="0"/>
             </a:endParaRPr>
           </a:p>
           <a:p>
             <a:r>
-              <a:rPr lang="en-US" sz="1600" b="1" dirty="0" smtClean="0">
+              <a:rPr lang="en-US" sz="1600" b="1" dirty="0">
                 <a:latin typeface="Arial" pitchFamily="34" charset="0"/>
                 <a:cs typeface="Arial" pitchFamily="34" charset="0"/>
               </a:rPr>
               <a:t>Coverage</a:t>
             </a:r>
             <a:r>
-              <a:rPr lang="ro-RO" sz="1600" b="1" dirty="0" smtClean="0">
+              <a:rPr lang="ro-RO" sz="1600" b="1" dirty="0">
                 <a:latin typeface="Arial" pitchFamily="34" charset="0"/>
                 <a:cs typeface="Arial" pitchFamily="34" charset="0"/>
               </a:rPr>
               <a:t>:</a:t>
             </a:r>
             <a:r>
-              <a:rPr lang="ro-RO" sz="1600" dirty="0" smtClean="0">
+              <a:rPr lang="ro-RO" sz="1600" dirty="0">
                 <a:latin typeface="Arial" pitchFamily="34" charset="0"/>
                 <a:cs typeface="Arial" pitchFamily="34" charset="0"/>
               </a:rPr>
@@ -4926,16 +4930,9 @@
                 <a:latin typeface="Arial" pitchFamily="34" charset="0"/>
                 <a:cs typeface="Arial" pitchFamily="34" charset="0"/>
               </a:rPr>
-              <a:t>coverage.py </a:t>
-            </a:r>
-            <a:r>
-              <a:rPr lang="en-US" sz="1600" dirty="0" smtClean="0">
-                <a:latin typeface="Arial" pitchFamily="34" charset="0"/>
-                <a:cs typeface="Arial" pitchFamily="34" charset="0"/>
-              </a:rPr>
-              <a:t>7.13.5</a:t>
-            </a:r>
-            <a:endParaRPr lang="ro-RO" sz="1600" dirty="0" smtClean="0">
+              <a:t>coverage.py 7.13.5</a:t>
+            </a:r>
+            <a:endParaRPr lang="ro-RO" sz="1600" dirty="0">
               <a:latin typeface="Arial" pitchFamily="34" charset="0"/>
               <a:cs typeface="Arial" pitchFamily="34" charset="0"/>
             </a:endParaRPr>
@@ -4946,17 +4943,10 @@
                 <a:latin typeface="Arial" pitchFamily="34" charset="0"/>
                 <a:cs typeface="Arial" pitchFamily="34" charset="0"/>
               </a:rPr>
-              <a:t>Mutation </a:t>
-            </a:r>
-            <a:r>
-              <a:rPr lang="en-US" sz="1600" b="1" dirty="0" smtClean="0">
-                <a:latin typeface="Arial" pitchFamily="34" charset="0"/>
-                <a:cs typeface="Arial" pitchFamily="34" charset="0"/>
-              </a:rPr>
-              <a:t>testing</a:t>
-            </a:r>
-            <a:r>
-              <a:rPr lang="ro-RO" sz="1600" b="1" dirty="0" smtClean="0">
+              <a:t>Mutation testing</a:t>
+            </a:r>
+            <a:r>
+              <a:rPr lang="ro-RO" sz="1600" b="1" dirty="0">
                 <a:latin typeface="Arial" pitchFamily="34" charset="0"/>
                 <a:cs typeface="Arial" pitchFamily="34" charset="0"/>
               </a:rPr>
@@ -4974,58 +4964,44 @@
                 <a:latin typeface="Arial" pitchFamily="34" charset="0"/>
                 <a:cs typeface="Arial" pitchFamily="34" charset="0"/>
               </a:rPr>
+              <a:t> 2.5.1</a:t>
+            </a:r>
+          </a:p>
+          <a:p>
+            <a:r>
+              <a:rPr lang="en-US" sz="1600" b="1" dirty="0" err="1">
+                <a:latin typeface="Arial" pitchFamily="34" charset="0"/>
+                <a:cs typeface="Arial" pitchFamily="34" charset="0"/>
+              </a:rPr>
+              <a:t>Mediu</a:t>
+            </a:r>
+            <a:r>
+              <a:rPr lang="en-US" sz="1600" b="1" dirty="0">
+                <a:latin typeface="Arial" pitchFamily="34" charset="0"/>
+                <a:cs typeface="Arial" pitchFamily="34" charset="0"/>
+              </a:rPr>
               <a:t> </a:t>
             </a:r>
             <a:r>
-              <a:rPr lang="en-US" sz="1600" dirty="0" smtClean="0">
-                <a:latin typeface="Arial" pitchFamily="34" charset="0"/>
-                <a:cs typeface="Arial" pitchFamily="34" charset="0"/>
-              </a:rPr>
-              <a:t>2.5.1</a:t>
-            </a:r>
-          </a:p>
-          <a:p>
-            <a:r>
-              <a:rPr lang="en-US" sz="1600" b="1" dirty="0" err="1" smtClean="0">
-                <a:latin typeface="Arial" pitchFamily="34" charset="0"/>
-                <a:cs typeface="Arial" pitchFamily="34" charset="0"/>
-              </a:rPr>
-              <a:t>Mediu</a:t>
-            </a:r>
-            <a:r>
-              <a:rPr lang="en-US" sz="1600" b="1" dirty="0" smtClean="0">
-                <a:latin typeface="Arial" pitchFamily="34" charset="0"/>
-                <a:cs typeface="Arial" pitchFamily="34" charset="0"/>
-              </a:rPr>
-              <a:t> </a:t>
-            </a:r>
-            <a:r>
-              <a:rPr lang="en-US" sz="1600" b="1" dirty="0" err="1" smtClean="0">
+              <a:rPr lang="en-US" sz="1600" b="1" dirty="0" err="1">
                 <a:latin typeface="Arial" pitchFamily="34" charset="0"/>
                 <a:cs typeface="Arial" pitchFamily="34" charset="0"/>
               </a:rPr>
               <a:t>rulare</a:t>
             </a:r>
             <a:r>
-              <a:rPr lang="ro-RO" sz="1600" b="1" dirty="0" smtClean="0">
+              <a:rPr lang="ro-RO" sz="1600" b="1" dirty="0">
                 <a:latin typeface="Arial" pitchFamily="34" charset="0"/>
                 <a:cs typeface="Arial" pitchFamily="34" charset="0"/>
               </a:rPr>
               <a:t>: </a:t>
             </a:r>
             <a:r>
-              <a:rPr lang="en-US" sz="1600" dirty="0" smtClean="0">
-                <a:latin typeface="Arial" pitchFamily="34" charset="0"/>
-                <a:cs typeface="Arial" pitchFamily="34" charset="0"/>
-              </a:rPr>
-              <a:t>Windows </a:t>
-            </a:r>
-            <a:r>
               <a:rPr lang="en-US" sz="1600" dirty="0">
                 <a:latin typeface="Arial" pitchFamily="34" charset="0"/>
                 <a:cs typeface="Arial" pitchFamily="34" charset="0"/>
               </a:rPr>
-              <a:t>11 Pro · Python 3.13.3 · WSL Ubuntu 24.04.1</a:t>
+              <a:t>Windows 11 Pro · Python 3.13.3 · WSL Ubuntu 24.04.1</a:t>
             </a:r>
           </a:p>
         </p:txBody>
@@ -5148,18 +5124,10 @@
           <a:p>
             <a:r>
               <a:rPr lang="it-IT" sz="2000" b="1" dirty="0"/>
-              <a:t>Utilizarea AI și rezultate </a:t>
-            </a:r>
-            <a:r>
-              <a:rPr lang="it-IT" sz="2000" b="1" dirty="0" smtClean="0"/>
-              <a:t>finale</a:t>
-            </a:r>
-            <a:r>
-              <a:rPr lang="ro-RO" sz="2000" b="1" dirty="0" smtClean="0"/>
-              <a:t/>
+              <a:t>Utilizarea AI și rezultate finale</a:t>
             </a:r>
             <a:br>
-              <a:rPr lang="ro-RO" sz="2000" b="1" dirty="0" smtClean="0"/>
+              <a:rPr lang="ro-RO" sz="2000" b="1" dirty="0"/>
             </a:br>
             <a:r>
               <a:rPr lang="vi-VN" sz="2000" dirty="0"/>
@@ -5556,28 +5524,28 @@
           <a:lstStyle/>
           <a:p>
             <a:r>
-              <a:rPr lang="en-US" sz="2200" b="1" dirty="0" err="1" smtClean="0">
+              <a:rPr lang="en-US" sz="2200" b="1" dirty="0" err="1">
                 <a:latin typeface="Arial" pitchFamily="34" charset="0"/>
                 <a:cs typeface="Arial" pitchFamily="34" charset="0"/>
               </a:rPr>
               <a:t>Metoda</a:t>
             </a:r>
             <a:r>
-              <a:rPr lang="en-US" sz="2200" b="1" dirty="0" smtClean="0">
+              <a:rPr lang="en-US" sz="2200" b="1" dirty="0">
                 <a:latin typeface="Arial" pitchFamily="34" charset="0"/>
                 <a:cs typeface="Arial" pitchFamily="34" charset="0"/>
               </a:rPr>
               <a:t> </a:t>
             </a:r>
             <a:r>
-              <a:rPr lang="vi-VN" sz="2200" b="1" dirty="0" smtClean="0">
+              <a:rPr lang="vi-VN" sz="2200" b="1" dirty="0">
                 <a:latin typeface="Arial" pitchFamily="34" charset="0"/>
                 <a:cs typeface="Arial" pitchFamily="34" charset="0"/>
               </a:rPr>
               <a:t>testată</a:t>
             </a:r>
             <a:r>
-              <a:rPr lang="en-US" sz="2200" b="1" dirty="0" smtClean="0">
+              <a:rPr lang="en-US" sz="2200" b="1" dirty="0">
                 <a:latin typeface="Arial" pitchFamily="34" charset="0"/>
                 <a:cs typeface="Arial" pitchFamily="34" charset="0"/>
               </a:rPr>
@@ -5671,7 +5639,7 @@
               <a:t> </a:t>
             </a:r>
             <a:r>
-              <a:rPr lang="en-US" b="1" dirty="0" err="1" smtClean="0">
+              <a:rPr lang="en-US" b="1" dirty="0" err="1">
                 <a:latin typeface="Tahoma" pitchFamily="34" charset="0"/>
                 <a:ea typeface="Tahoma" pitchFamily="34" charset="0"/>
                 <a:cs typeface="Tahoma" pitchFamily="34" charset="0"/>
@@ -5679,7 +5647,7 @@
               <a:t>metodei</a:t>
             </a:r>
             <a:r>
-              <a:rPr lang="en-US" b="1" dirty="0" smtClean="0">
+              <a:rPr lang="en-US" b="1" dirty="0">
                 <a:latin typeface="Tahoma" pitchFamily="34" charset="0"/>
                 <a:ea typeface="Tahoma" pitchFamily="34" charset="0"/>
                 <a:cs typeface="Tahoma" pitchFamily="34" charset="0"/>
@@ -5689,7 +5657,7 @@
           </a:p>
           <a:p>
             <a:r>
-              <a:rPr lang="vi-VN" b="1" dirty="0" smtClean="0">
+              <a:rPr lang="vi-VN" b="1" dirty="0">
                 <a:latin typeface="Tahoma" pitchFamily="34" charset="0"/>
                 <a:ea typeface="Tahoma" pitchFamily="34" charset="0"/>
                 <a:cs typeface="Tahoma" pitchFamily="34" charset="0"/>
@@ -5793,100 +5761,87 @@
               </a:rPr>
               <a:t>) </a:t>
             </a:r>
-            <a:endParaRPr lang="en-US" dirty="0" smtClean="0">
+          </a:p>
+          <a:p>
+            <a:r>
+              <a:rPr lang="en-US" dirty="0">
+                <a:latin typeface="Tahoma" pitchFamily="34" charset="0"/>
+                <a:ea typeface="Tahoma" pitchFamily="34" charset="0"/>
+                <a:cs typeface="Tahoma" pitchFamily="34" charset="0"/>
+              </a:rPr>
+              <a:t>result = </a:t>
+            </a:r>
+            <a:r>
+              <a:rPr lang="en-US" dirty="0" err="1">
+                <a:latin typeface="Tahoma" pitchFamily="34" charset="0"/>
+                <a:ea typeface="Tahoma" pitchFamily="34" charset="0"/>
+                <a:cs typeface="Tahoma" pitchFamily="34" charset="0"/>
+              </a:rPr>
+              <a:t>booking.evaluate_client_package</a:t>
+            </a:r>
+            <a:r>
+              <a:rPr lang="en-US" dirty="0">
+                <a:latin typeface="Tahoma" pitchFamily="34" charset="0"/>
+                <a:ea typeface="Tahoma" pitchFamily="34" charset="0"/>
+                <a:cs typeface="Tahoma" pitchFamily="34" charset="0"/>
+              </a:rPr>
+              <a:t>(</a:t>
+            </a:r>
+            <a:r>
+              <a:rPr lang="en-US" dirty="0" err="1">
+                <a:latin typeface="Tahoma" pitchFamily="34" charset="0"/>
+                <a:ea typeface="Tahoma" pitchFamily="34" charset="0"/>
+                <a:cs typeface="Tahoma" pitchFamily="34" charset="0"/>
+              </a:rPr>
+              <a:t>session_history</a:t>
+            </a:r>
+            <a:r>
+              <a:rPr lang="en-US" dirty="0">
+                <a:latin typeface="Tahoma" pitchFamily="34" charset="0"/>
+                <a:ea typeface="Tahoma" pitchFamily="34" charset="0"/>
+                <a:cs typeface="Tahoma" pitchFamily="34" charset="0"/>
+              </a:rPr>
+              <a:t>, </a:t>
+            </a:r>
+            <a:r>
+              <a:rPr lang="en-US" dirty="0" err="1">
+                <a:latin typeface="Tahoma" pitchFamily="34" charset="0"/>
+                <a:ea typeface="Tahoma" pitchFamily="34" charset="0"/>
+                <a:cs typeface="Tahoma" pitchFamily="34" charset="0"/>
+              </a:rPr>
+              <a:t>package_sessions</a:t>
+            </a:r>
+            <a:r>
+              <a:rPr lang="en-US" dirty="0">
+                <a:latin typeface="Tahoma" pitchFamily="34" charset="0"/>
+                <a:ea typeface="Tahoma" pitchFamily="34" charset="0"/>
+                <a:cs typeface="Tahoma" pitchFamily="34" charset="0"/>
+              </a:rPr>
+              <a:t>, </a:t>
+            </a:r>
+            <a:r>
+              <a:rPr lang="en-US" dirty="0" err="1">
+                <a:latin typeface="Tahoma" pitchFamily="34" charset="0"/>
+                <a:ea typeface="Tahoma" pitchFamily="34" charset="0"/>
+                <a:cs typeface="Tahoma" pitchFamily="34" charset="0"/>
+              </a:rPr>
+              <a:t>has_membership</a:t>
+            </a:r>
+            <a:r>
+              <a:rPr lang="en-US" dirty="0">
+                <a:latin typeface="Tahoma" pitchFamily="34" charset="0"/>
+                <a:ea typeface="Tahoma" pitchFamily="34" charset="0"/>
+                <a:cs typeface="Tahoma" pitchFamily="34" charset="0"/>
+              </a:rPr>
+              <a:t>)</a:t>
+            </a:r>
+            <a:endParaRPr lang="en-US" b="1" dirty="0">
               <a:latin typeface="Tahoma" pitchFamily="34" charset="0"/>
               <a:ea typeface="Tahoma" pitchFamily="34" charset="0"/>
               <a:cs typeface="Tahoma" pitchFamily="34" charset="0"/>
             </a:endParaRPr>
           </a:p>
           <a:p>
-            <a:r>
-              <a:rPr lang="en-US" dirty="0" smtClean="0">
-                <a:latin typeface="Tahoma" pitchFamily="34" charset="0"/>
-                <a:ea typeface="Tahoma" pitchFamily="34" charset="0"/>
-                <a:cs typeface="Tahoma" pitchFamily="34" charset="0"/>
-              </a:rPr>
-              <a:t>result </a:t>
-            </a:r>
-            <a:r>
-              <a:rPr lang="en-US" dirty="0">
-                <a:latin typeface="Tahoma" pitchFamily="34" charset="0"/>
-                <a:ea typeface="Tahoma" pitchFamily="34" charset="0"/>
-                <a:cs typeface="Tahoma" pitchFamily="34" charset="0"/>
-              </a:rPr>
-              <a:t>= </a:t>
-            </a:r>
-            <a:r>
-              <a:rPr lang="en-US" dirty="0" err="1">
-                <a:latin typeface="Tahoma" pitchFamily="34" charset="0"/>
-                <a:ea typeface="Tahoma" pitchFamily="34" charset="0"/>
-                <a:cs typeface="Tahoma" pitchFamily="34" charset="0"/>
-              </a:rPr>
-              <a:t>booking.evaluate_client_package</a:t>
-            </a:r>
-            <a:r>
-              <a:rPr lang="en-US" dirty="0">
-                <a:latin typeface="Tahoma" pitchFamily="34" charset="0"/>
-                <a:ea typeface="Tahoma" pitchFamily="34" charset="0"/>
-                <a:cs typeface="Tahoma" pitchFamily="34" charset="0"/>
-              </a:rPr>
-              <a:t>(</a:t>
-            </a:r>
-            <a:r>
-              <a:rPr lang="en-US" dirty="0" err="1">
-                <a:latin typeface="Tahoma" pitchFamily="34" charset="0"/>
-                <a:ea typeface="Tahoma" pitchFamily="34" charset="0"/>
-                <a:cs typeface="Tahoma" pitchFamily="34" charset="0"/>
-              </a:rPr>
-              <a:t>session_history</a:t>
-            </a:r>
-            <a:r>
-              <a:rPr lang="en-US" dirty="0">
-                <a:latin typeface="Tahoma" pitchFamily="34" charset="0"/>
-                <a:ea typeface="Tahoma" pitchFamily="34" charset="0"/>
-                <a:cs typeface="Tahoma" pitchFamily="34" charset="0"/>
-              </a:rPr>
-              <a:t>, </a:t>
-            </a:r>
-            <a:r>
-              <a:rPr lang="en-US" dirty="0" err="1">
-                <a:latin typeface="Tahoma" pitchFamily="34" charset="0"/>
-                <a:ea typeface="Tahoma" pitchFamily="34" charset="0"/>
-                <a:cs typeface="Tahoma" pitchFamily="34" charset="0"/>
-              </a:rPr>
-              <a:t>package_sessions</a:t>
-            </a:r>
-            <a:r>
-              <a:rPr lang="en-US" dirty="0">
-                <a:latin typeface="Tahoma" pitchFamily="34" charset="0"/>
-                <a:ea typeface="Tahoma" pitchFamily="34" charset="0"/>
-                <a:cs typeface="Tahoma" pitchFamily="34" charset="0"/>
-              </a:rPr>
-              <a:t>, </a:t>
-            </a:r>
-            <a:r>
-              <a:rPr lang="en-US" dirty="0" err="1">
-                <a:latin typeface="Tahoma" pitchFamily="34" charset="0"/>
-                <a:ea typeface="Tahoma" pitchFamily="34" charset="0"/>
-                <a:cs typeface="Tahoma" pitchFamily="34" charset="0"/>
-              </a:rPr>
-              <a:t>has_membership</a:t>
-            </a:r>
-            <a:r>
-              <a:rPr lang="en-US" dirty="0" smtClean="0">
-                <a:latin typeface="Tahoma" pitchFamily="34" charset="0"/>
-                <a:ea typeface="Tahoma" pitchFamily="34" charset="0"/>
-                <a:cs typeface="Tahoma" pitchFamily="34" charset="0"/>
-              </a:rPr>
-              <a:t>)</a:t>
-            </a:r>
-            <a:endParaRPr lang="en-US" b="1" dirty="0" smtClean="0">
-              <a:latin typeface="Tahoma" pitchFamily="34" charset="0"/>
-              <a:ea typeface="Tahoma" pitchFamily="34" charset="0"/>
-              <a:cs typeface="Tahoma" pitchFamily="34" charset="0"/>
-            </a:endParaRPr>
-          </a:p>
-          <a:p>
             <a:pPr marL="0" indent="0">
               <a:buNone/>
             </a:pPr>
@@ -5907,7 +5862,7 @@
               <a:t> din </a:t>
             </a:r>
             <a:r>
-              <a:rPr lang="en-US" b="1" dirty="0" err="1" smtClean="0">
+              <a:rPr lang="en-US" b="1" dirty="0" err="1">
                 <a:latin typeface="Tahoma" pitchFamily="34" charset="0"/>
                 <a:ea typeface="Tahoma" pitchFamily="34" charset="0"/>
                 <a:cs typeface="Tahoma" pitchFamily="34" charset="0"/>
@@ -5915,7 +5870,7 @@
               <a:t>session_history</a:t>
             </a:r>
             <a:r>
-              <a:rPr lang="en-US" b="1" dirty="0" smtClean="0">
+              <a:rPr lang="en-US" b="1" dirty="0">
                 <a:latin typeface="Tahoma" pitchFamily="34" charset="0"/>
                 <a:ea typeface="Tahoma" pitchFamily="34" charset="0"/>
                 <a:cs typeface="Tahoma" pitchFamily="34" charset="0"/>
@@ -6336,7 +6291,7 @@
               <a:buNone/>
             </a:pPr>
             <a:r>
-              <a:rPr lang="en-US" sz="1400" b="1" dirty="0" err="1" smtClean="0">
+              <a:rPr lang="en-US" sz="1400" b="1" dirty="0" err="1">
                 <a:latin typeface="Tahoma" pitchFamily="34" charset="0"/>
                 <a:ea typeface="Tahoma" pitchFamily="34" charset="0"/>
                 <a:cs typeface="Tahoma" pitchFamily="34" charset="0"/>
@@ -6344,7 +6299,7 @@
               <a:t>Exemplu</a:t>
             </a:r>
             <a:r>
-              <a:rPr lang="en-US" sz="1400" b="1" dirty="0" smtClean="0">
+              <a:rPr lang="en-US" sz="1400" b="1" dirty="0">
                 <a:latin typeface="Tahoma" pitchFamily="34" charset="0"/>
                 <a:ea typeface="Tahoma" pitchFamily="34" charset="0"/>
                 <a:cs typeface="Tahoma" pitchFamily="34" charset="0"/>
@@ -6357,7 +6312,7 @@
               <a:buNone/>
             </a:pPr>
             <a:r>
-              <a:rPr lang="en-US" sz="1400" b="1" dirty="0" smtClean="0">
+              <a:rPr lang="en-US" sz="1400" b="1" dirty="0">
                 <a:latin typeface="Tahoma" pitchFamily="34" charset="0"/>
                 <a:ea typeface="Tahoma" pitchFamily="34" charset="0"/>
                 <a:cs typeface="Tahoma" pitchFamily="34" charset="0"/>
@@ -6365,14 +6320,14 @@
               <a:t> </a:t>
             </a:r>
             <a:br>
-              <a:rPr lang="en-US" sz="1400" b="1" dirty="0" smtClean="0">
+              <a:rPr lang="en-US" sz="1400" b="1" dirty="0">
                 <a:latin typeface="Tahoma" pitchFamily="34" charset="0"/>
                 <a:ea typeface="Tahoma" pitchFamily="34" charset="0"/>
                 <a:cs typeface="Tahoma" pitchFamily="34" charset="0"/>
               </a:rPr>
             </a:br>
             <a:r>
-              <a:rPr lang="en-US" sz="1400" b="1" dirty="0" smtClean="0">
+              <a:rPr lang="en-US" sz="1400" b="1" dirty="0">
                 <a:latin typeface="Tahoma" pitchFamily="34" charset="0"/>
                 <a:ea typeface="Tahoma" pitchFamily="34" charset="0"/>
                 <a:cs typeface="Tahoma" pitchFamily="34" charset="0"/>
@@ -6659,7 +6614,7 @@
               <a:buNone/>
             </a:pPr>
             <a:r>
-              <a:rPr lang="en-US" sz="1400" b="1" dirty="0" smtClean="0">
+              <a:rPr lang="en-US" sz="1400" b="1" dirty="0">
                 <a:latin typeface="Tahoma" pitchFamily="34" charset="0"/>
                 <a:ea typeface="Tahoma" pitchFamily="34" charset="0"/>
                 <a:cs typeface="Tahoma" pitchFamily="34" charset="0"/>
@@ -6668,11 +6623,7 @@
             </a:r>
             <a:r>
               <a:rPr lang="en-US" sz="1400" dirty="0"/>
-              <a:t>attended=2 </a:t>
-            </a:r>
-            <a:r>
-              <a:rPr lang="en-US" sz="1400" dirty="0" smtClean="0"/>
-              <a:t>; </a:t>
+              <a:t>attended=2 ; </a:t>
             </a:r>
             <a:r>
               <a:rPr lang="en-US" sz="1400" dirty="0" err="1"/>
@@ -6680,26 +6631,14 @@
             </a:r>
             <a:r>
               <a:rPr lang="en-US" sz="1400" dirty="0"/>
-              <a:t>=1 </a:t>
-            </a:r>
-            <a:r>
-              <a:rPr lang="en-US" sz="1400" dirty="0" smtClean="0"/>
-              <a:t>; </a:t>
+              <a:t>=1 ; cancelled=1 ; </a:t>
+            </a:r>
+            <a:r>
+              <a:rPr lang="en-US" sz="1400" dirty="0" err="1"/>
+              <a:t>used_sessions</a:t>
             </a:r>
             <a:r>
               <a:rPr lang="en-US" sz="1400" dirty="0"/>
-              <a:t>cancelled=1 </a:t>
-            </a:r>
-            <a:r>
-              <a:rPr lang="en-US" sz="1400" dirty="0" smtClean="0"/>
-              <a:t>; </a:t>
-            </a:r>
-            <a:r>
-              <a:rPr lang="en-US" sz="1400" dirty="0" err="1" smtClean="0"/>
-              <a:t>used_sessions</a:t>
-            </a:r>
-            <a:r>
-              <a:rPr lang="en-US" sz="1400" dirty="0" smtClean="0"/>
               <a:t>=3 ; remaining=2 ; </a:t>
             </a:r>
             <a:r>
@@ -6708,15 +6647,7 @@
             </a:r>
             <a:r>
               <a:rPr lang="en-US" sz="1400" dirty="0"/>
-              <a:t> = 5 × 50 × 0.80 = 200.0 </a:t>
-            </a:r>
-            <a:r>
-              <a:rPr lang="en-US" sz="1400" dirty="0" smtClean="0"/>
-              <a:t>; status </a:t>
-            </a:r>
-            <a:r>
-              <a:rPr lang="en-US" sz="1400" dirty="0"/>
-              <a:t>= "active"</a:t>
+              <a:t> = 5 × 50 × 0.80 = 200.0 ; status = "active"</a:t>
             </a:r>
             <a:endParaRPr lang="en-US" sz="1400" b="1" dirty="0">
               <a:latin typeface="Tahoma" pitchFamily="34" charset="0"/>
@@ -6777,22 +6708,21 @@
           <a:lstStyle/>
           <a:p>
             <a:r>
-              <a:rPr lang="en-US" dirty="0" err="1" smtClean="0"/>
+              <a:rPr lang="en-US" dirty="0" err="1"/>
               <a:t>Strategiile</a:t>
             </a:r>
             <a:r>
-              <a:rPr lang="en-US" dirty="0" smtClean="0"/>
+              <a:rPr lang="en-US" dirty="0"/>
               <a:t> de </a:t>
             </a:r>
             <a:r>
-              <a:rPr lang="en-US" dirty="0" err="1" smtClean="0"/>
+              <a:rPr lang="en-US" dirty="0" err="1"/>
               <a:t>testare</a:t>
             </a:r>
             <a:r>
-              <a:rPr lang="en-US" dirty="0" smtClean="0"/>
+              <a:rPr lang="en-US" dirty="0"/>
               <a:t> </a:t>
             </a:r>
-            <a:endParaRPr lang="en-US" dirty="0"/>
           </a:p>
         </p:txBody>
       </p:sp>
@@ -6963,11 +6893,11 @@
           </a:lstStyle>
           <a:p>
             <a:r>
-              <a:rPr lang="en-US" dirty="0" err="1" smtClean="0"/>
+              <a:rPr lang="en-US" dirty="0" err="1"/>
               <a:t>Distribu</a:t>
             </a:r>
             <a:r>
-              <a:rPr lang="ro-RO" dirty="0" smtClean="0"/>
+              <a:rPr lang="ro-RO" dirty="0"/>
               <a:t>tia celor 100 de teste</a:t>
             </a:r>
             <a:endParaRPr lang="en-US" dirty="0"/>
@@ -7139,7 +7069,7 @@
           </a:lstStyle>
           <a:p>
             <a:r>
-              <a:rPr lang="ro-RO" sz="2000" dirty="0" smtClean="0"/>
+              <a:rPr lang="ro-RO" sz="2000" dirty="0"/>
               <a:t>Obiectul verificat de teste – outputul metodei</a:t>
             </a:r>
             <a:endParaRPr lang="en-US" sz="2000" dirty="0"/>
@@ -7233,39 +7163,23 @@
           <a:p>
             <a:r>
               <a:rPr lang="vi-VN" dirty="0"/>
-              <a:t>Testele verifică fiecare câmp din acest </a:t>
-            </a:r>
-            <a:r>
-              <a:rPr lang="vi-VN" dirty="0" smtClean="0"/>
-              <a:t>dicționar</a:t>
-            </a:r>
-            <a:r>
-              <a:rPr lang="ro-RO" dirty="0" smtClean="0"/>
+              <a:t>Testele verifică fiecare câmp din acest dicționar</a:t>
+            </a:r>
+            <a:r>
+              <a:rPr lang="ro-RO" dirty="0"/>
               <a:t> (</a:t>
             </a:r>
             <a:r>
-              <a:rPr lang="vi-VN" dirty="0" smtClean="0"/>
-              <a:t>atât </a:t>
-            </a:r>
-            <a:r>
               <a:rPr lang="vi-VN" dirty="0"/>
-              <a:t>individual, cât și </a:t>
-            </a:r>
-            <a:r>
-              <a:rPr lang="vi-VN" dirty="0" smtClean="0"/>
-              <a:t>combinat</a:t>
-            </a:r>
-            <a:r>
-              <a:rPr lang="ro-RO" dirty="0" smtClean="0"/>
+              <a:t>atât individual, cât și combinat</a:t>
+            </a:r>
+            <a:r>
+              <a:rPr lang="ro-RO" dirty="0"/>
               <a:t>)</a:t>
             </a:r>
             <a:r>
-              <a:rPr lang="vi-VN" dirty="0" smtClean="0"/>
-              <a:t> </a:t>
-            </a:r>
-            <a:r>
               <a:rPr lang="vi-VN" dirty="0"/>
-              <a:t>pentru a confirma că logica metodei este corectă.</a:t>
+              <a:t> pentru a confirma că logica metodei este corectă.</a:t>
             </a:r>
             <a:endParaRPr lang="en-US" dirty="0"/>
           </a:p>
@@ -7323,11 +7237,7 @@
           <a:p>
             <a:r>
               <a:rPr lang="nb-NO" b="1" dirty="0"/>
-              <a:t>Validări și reguli de </a:t>
-            </a:r>
-            <a:r>
-              <a:rPr lang="nb-NO" b="1" dirty="0" smtClean="0"/>
-              <a:t>business</a:t>
+              <a:t>Validări și reguli de business</a:t>
             </a:r>
             <a:endParaRPr lang="en-US" dirty="0"/>
           </a:p>
@@ -7355,11 +7265,7 @@
           <a:p>
             <a:r>
               <a:rPr lang="vi-VN" b="1" dirty="0"/>
-              <a:t>Validări constructor __init</a:t>
-            </a:r>
-            <a:r>
-              <a:rPr lang="vi-VN" b="1" dirty="0" smtClean="0"/>
-              <a:t>__</a:t>
+              <a:t>Validări constructor __init__</a:t>
             </a:r>
             <a:endParaRPr lang="ro-RO" b="1" dirty="0"/>
           </a:p>
@@ -7367,7 +7273,7 @@
             <a:pPr marL="0" indent="0">
               <a:buNone/>
             </a:pPr>
-            <a:endParaRPr lang="ro-RO" b="1" dirty="0" smtClean="0"/>
+            <a:endParaRPr lang="ro-RO" b="1" dirty="0"/>
           </a:p>
           <a:p>
             <a:pPr marL="0" indent="0">
@@ -7378,36 +7284,28 @@
           <a:p>
             <a:r>
               <a:rPr lang="vi-VN" b="1" dirty="0"/>
-              <a:t>Validări metodă </a:t>
-            </a:r>
-            <a:r>
-              <a:rPr lang="vi-VN" b="1" dirty="0" smtClean="0"/>
-              <a:t>evaluate_client_package</a:t>
-            </a:r>
-            <a:endParaRPr lang="ro-RO" b="1" dirty="0" smtClean="0"/>
-          </a:p>
-          <a:p>
+              <a:t>Validări metodă evaluate_client_package</a:t>
+            </a:r>
             <a:endParaRPr lang="ro-RO" b="1" dirty="0"/>
           </a:p>
           <a:p>
-            <a:endParaRPr lang="ro-RO" b="1" dirty="0" smtClean="0"/>
+            <a:endParaRPr lang="ro-RO" b="1" dirty="0"/>
+          </a:p>
+          <a:p>
+            <a:endParaRPr lang="ro-RO" b="1" dirty="0"/>
           </a:p>
           <a:p>
             <a:pPr marL="0" indent="0">
               <a:buNone/>
             </a:pPr>
-            <a:endParaRPr lang="ro-RO" dirty="0" smtClean="0"/>
+            <a:endParaRPr lang="ro-RO" dirty="0"/>
           </a:p>
           <a:p>
             <a:r>
               <a:rPr lang="vi-VN" b="1" dirty="0"/>
-              <a:t>Cazul special bool / </a:t>
-            </a:r>
-            <a:r>
-              <a:rPr lang="vi-VN" b="1" dirty="0" smtClean="0"/>
-              <a:t>int</a:t>
-            </a:r>
-            <a:endParaRPr lang="ro-RO" b="1" dirty="0" smtClean="0"/>
+              <a:t>Cazul special bool / int</a:t>
+            </a:r>
+            <a:endParaRPr lang="ro-RO" b="1" dirty="0"/>
           </a:p>
           <a:p>
             <a:endParaRPr lang="ro-RO" b="1" dirty="0"/>
@@ -7416,14 +7314,13 @@
             <a:pPr marL="0" indent="0">
               <a:buNone/>
             </a:pPr>
-            <a:endParaRPr lang="ro-RO" b="1" dirty="0" smtClean="0"/>
+            <a:endParaRPr lang="ro-RO" b="1" dirty="0"/>
           </a:p>
           <a:p>
             <a:r>
               <a:rPr lang="vi-VN" b="1" dirty="0"/>
               <a:t>Formula costului</a:t>
             </a:r>
-            <a:endParaRPr lang="vi-VN" b="1" dirty="0"/>
           </a:p>
         </p:txBody>
       </p:sp>
@@ -7764,7 +7661,7 @@
               <a:t> clase de </a:t>
             </a:r>
             <a:r>
-              <a:rPr lang="es-ES" sz="2000" b="1" dirty="0" err="1" smtClean="0">
+              <a:rPr lang="es-ES" sz="2000" b="1" dirty="0" err="1">
                 <a:latin typeface="Arial" pitchFamily="34" charset="0"/>
                 <a:cs typeface="Arial" pitchFamily="34" charset="0"/>
               </a:rPr>
@@ -7775,17 +7672,10 @@
                 <a:latin typeface="Arial" pitchFamily="34" charset="0"/>
                 <a:cs typeface="Arial" pitchFamily="34" charset="0"/>
               </a:rPr>
-              <a:t> </a:t>
-            </a:r>
-            <a:r>
-              <a:rPr lang="ro-RO" sz="2000" b="1" dirty="0" smtClean="0">
-                <a:latin typeface="Arial" pitchFamily="34" charset="0"/>
-                <a:cs typeface="Arial" pitchFamily="34" charset="0"/>
-              </a:rPr>
-              <a:t>– 23 de teste</a:t>
+              <a:t> – 23 de teste</a:t>
             </a:r>
             <a:br>
-              <a:rPr lang="ro-RO" sz="2000" b="1" dirty="0" smtClean="0">
+              <a:rPr lang="ro-RO" sz="2000" b="1" dirty="0">
                 <a:latin typeface="Arial" pitchFamily="34" charset="0"/>
                 <a:cs typeface="Arial" pitchFamily="34" charset="0"/>
               </a:rPr>
@@ -7876,22 +7766,18 @@
             </a:r>
             <a:r>
               <a:rPr lang="en-US" dirty="0"/>
-              <a:t> </a:t>
-            </a:r>
-            <a:r>
-              <a:rPr lang="en-US" dirty="0" smtClean="0"/>
-              <a:t>(</a:t>
-            </a:r>
-            <a:r>
-              <a:rPr lang="ro-RO" dirty="0" smtClean="0"/>
+              <a:t> (</a:t>
+            </a:r>
+            <a:r>
+              <a:rPr lang="ro-RO" dirty="0"/>
               <a:t>=</a:t>
             </a:r>
             <a:r>
-              <a:rPr lang="en-US" dirty="0" smtClean="0"/>
+              <a:rPr lang="en-US" dirty="0"/>
               <a:t>&gt; </a:t>
             </a:r>
             <a:r>
-              <a:rPr lang="en-US" dirty="0" err="1" smtClean="0"/>
+              <a:rPr lang="en-US" dirty="0" err="1"/>
               <a:t>ValueError</a:t>
             </a:r>
             <a:r>
@@ -8122,14 +8008,10 @@
           <a:p>
             <a:r>
               <a:rPr lang="vi-VN" b="1" dirty="0"/>
-              <a:t>Analiza valorilor de </a:t>
-            </a:r>
-            <a:r>
-              <a:rPr lang="vi-VN" b="1" dirty="0" smtClean="0"/>
-              <a:t>frontieră</a:t>
-            </a:r>
-            <a:r>
-              <a:rPr lang="ro-RO" b="1" dirty="0" smtClean="0"/>
+              <a:t>Analiza valorilor de frontieră</a:t>
+            </a:r>
+            <a:r>
+              <a:rPr lang="ro-RO" b="1" dirty="0"/>
               <a:t> – 16 teste</a:t>
             </a:r>
             <a:endParaRPr lang="en-US" dirty="0"/>
@@ -8174,11 +8056,11 @@
               <a:t> </a:t>
             </a:r>
             <a:r>
-              <a:rPr lang="ro-RO" dirty="0" smtClean="0"/>
+              <a:rPr lang="ro-RO" dirty="0"/>
               <a:t>--</a:t>
             </a:r>
             <a:r>
-              <a:rPr lang="fr-FR" dirty="0" smtClean="0"/>
+              <a:rPr lang="fr-FR" dirty="0"/>
               <a:t> </a:t>
             </a:r>
             <a:r>
@@ -8295,11 +8177,11 @@
               <a:t> </a:t>
             </a:r>
             <a:r>
-              <a:rPr lang="ro-RO" dirty="0" smtClean="0"/>
+              <a:rPr lang="ro-RO" dirty="0"/>
               <a:t>--</a:t>
             </a:r>
             <a:r>
-              <a:rPr lang="en-US" dirty="0" smtClean="0"/>
+              <a:rPr lang="en-US" dirty="0"/>
               <a:t> </a:t>
             </a:r>
             <a:r>
@@ -8467,20 +8349,16 @@
               <a:t>Frontierele </a:t>
             </a:r>
             <a:r>
-              <a:rPr lang="vi-VN" b="1" dirty="0" smtClean="0"/>
+              <a:rPr lang="vi-VN" b="1" dirty="0"/>
               <a:t>instructor</a:t>
             </a:r>
             <a:r>
-              <a:rPr lang="ro-RO" dirty="0" smtClean="0"/>
+              <a:rPr lang="ro-RO" dirty="0"/>
               <a:t> --</a:t>
             </a:r>
             <a:r>
-              <a:rPr lang="vi-VN" dirty="0" smtClean="0"/>
-              <a:t> </a:t>
-            </a:r>
-            <a:r>
               <a:rPr lang="vi-VN" dirty="0"/>
-              <a:t>lungime după strip()</a:t>
+              <a:t> lungime după strip()</a:t>
             </a:r>
             <a:endParaRPr lang="en-US" dirty="0"/>
           </a:p>
@@ -8520,16 +8398,12 @@
               <a:t> </a:t>
             </a:r>
             <a:r>
-              <a:rPr lang="ro-RO" dirty="0" smtClean="0"/>
+              <a:rPr lang="ro-RO" dirty="0"/>
               <a:t>--</a:t>
             </a:r>
             <a:r>
-              <a:rPr lang="vi-VN" dirty="0" smtClean="0"/>
-              <a:t> </a:t>
-            </a:r>
-            <a:r>
               <a:rPr lang="vi-VN" dirty="0"/>
-              <a:t>momentul completării pachetului</a:t>
+              <a:t> momentul completării pachetului</a:t>
             </a:r>
             <a:endParaRPr lang="en-US" dirty="0"/>
           </a:p>
@@ -8656,24 +8530,17 @@
                 <a:latin typeface="Arial" pitchFamily="34" charset="0"/>
                 <a:cs typeface="Arial" pitchFamily="34" charset="0"/>
               </a:rPr>
-              <a:t>Acoperire structurală: instrucțiune, decizie, </a:t>
-            </a:r>
-            <a:r>
-              <a:rPr lang="it-IT" sz="2000" b="1" dirty="0" smtClean="0">
-                <a:latin typeface="Arial" pitchFamily="34" charset="0"/>
-                <a:cs typeface="Arial" pitchFamily="34" charset="0"/>
-              </a:rPr>
-              <a:t>condiție</a:t>
-            </a:r>
-            <a:r>
-              <a:rPr lang="ro-RO" sz="2000" b="1" dirty="0" smtClean="0">
+              <a:t>Acoperire structurală: instrucțiune, decizie, condiție</a:t>
+            </a:r>
+            <a:r>
+              <a:rPr lang="ro-RO" sz="2000" b="1" dirty="0">
                 <a:latin typeface="Arial" pitchFamily="34" charset="0"/>
                 <a:cs typeface="Arial" pitchFamily="34" charset="0"/>
               </a:rPr>
               <a:t> – 40 de teste</a:t>
             </a:r>
             <a:br>
-              <a:rPr lang="ro-RO" sz="2000" b="1" dirty="0" smtClean="0">
+              <a:rPr lang="ro-RO" sz="2000" b="1" dirty="0">
                 <a:latin typeface="Arial" pitchFamily="34" charset="0"/>
                 <a:cs typeface="Arial" pitchFamily="34" charset="0"/>
               </a:rPr>
@@ -8718,14 +8585,7 @@
                 <a:latin typeface="Arial" pitchFamily="34" charset="0"/>
                 <a:cs typeface="Arial" pitchFamily="34" charset="0"/>
               </a:rPr>
-              <a:t>100</a:t>
-            </a:r>
-            <a:r>
-              <a:rPr lang="en-US" sz="2000" b="1" dirty="0" smtClean="0">
-                <a:latin typeface="Arial" pitchFamily="34" charset="0"/>
-                <a:cs typeface="Arial" pitchFamily="34" charset="0"/>
-              </a:rPr>
-              <a:t>%</a:t>
+              <a:t>100%</a:t>
             </a:r>
             <a:endParaRPr lang="en-US" sz="2000" dirty="0">
               <a:latin typeface="Arial" pitchFamily="34" charset="0"/>
@@ -8771,14 +8631,14 @@
               <a:t> </a:t>
             </a:r>
             <a:r>
-              <a:rPr lang="en-US" sz="1600" b="1" dirty="0" err="1" smtClean="0">
+              <a:rPr lang="en-US" sz="1600" b="1" dirty="0" err="1">
                 <a:latin typeface="Arial" pitchFamily="34" charset="0"/>
                 <a:cs typeface="Arial" pitchFamily="34" charset="0"/>
               </a:rPr>
               <a:t>instrucțiune</a:t>
             </a:r>
             <a:r>
-              <a:rPr lang="ro-RO" sz="1600" b="1" dirty="0" smtClean="0">
+              <a:rPr lang="ro-RO" sz="1600" b="1" dirty="0">
                 <a:latin typeface="Arial" pitchFamily="34" charset="0"/>
                 <a:cs typeface="Arial" pitchFamily="34" charset="0"/>
               </a:rPr>
@@ -8803,22 +8663,15 @@
                 <a:latin typeface="Arial" pitchFamily="34" charset="0"/>
                 <a:cs typeface="Arial" pitchFamily="34" charset="0"/>
               </a:rPr>
-              <a:t> este executată cel puțin o dată</a:t>
-            </a:r>
-            <a:r>
-              <a:rPr lang="vi-VN" sz="1600" dirty="0" smtClean="0">
-                <a:latin typeface="Arial" pitchFamily="34" charset="0"/>
-                <a:cs typeface="Arial" pitchFamily="34" charset="0"/>
-              </a:rPr>
-              <a:t>.</a:t>
-            </a:r>
-            <a:endParaRPr lang="ro-RO" sz="1600" dirty="0" smtClean="0">
+              <a:t> este executată cel puțin o dată.</a:t>
+            </a:r>
+            <a:endParaRPr lang="ro-RO" sz="1600" dirty="0">
               <a:latin typeface="Arial" pitchFamily="34" charset="0"/>
               <a:cs typeface="Arial" pitchFamily="34" charset="0"/>
             </a:endParaRPr>
           </a:p>
           <a:p>
-            <a:endParaRPr lang="ro-RO" sz="1600" dirty="0" smtClean="0">
+            <a:endParaRPr lang="ro-RO" sz="1600" dirty="0">
               <a:latin typeface="Arial" pitchFamily="34" charset="0"/>
               <a:cs typeface="Arial" pitchFamily="34" charset="0"/>
             </a:endParaRPr>
@@ -8836,223 +8689,97 @@
             <a:pPr marL="0" indent="0">
               <a:buNone/>
             </a:pPr>
-            <a:endParaRPr lang="ro-RO" sz="1600" dirty="0" smtClean="0">
-              <a:latin typeface="Arial" pitchFamily="34" charset="0"/>
-              <a:cs typeface="Arial" pitchFamily="34" charset="0"/>
-            </a:endParaRPr>
-          </a:p>
-          <a:p>
-            <a:r>
-              <a:rPr lang="en-US" sz="1600" b="1" dirty="0" err="1">
-                <a:latin typeface="Arial" pitchFamily="34" charset="0"/>
-                <a:cs typeface="Arial" pitchFamily="34" charset="0"/>
-              </a:rPr>
-              <a:t>Acoperire</a:t>
-            </a:r>
-            <a:r>
-              <a:rPr lang="en-US" sz="1600" b="1" dirty="0">
-                <a:latin typeface="Arial" pitchFamily="34" charset="0"/>
-                <a:cs typeface="Arial" pitchFamily="34" charset="0"/>
-              </a:rPr>
-              <a:t> </a:t>
-            </a:r>
-            <a:r>
-              <a:rPr lang="en-US" sz="1600" b="1" dirty="0" err="1" smtClean="0">
-                <a:latin typeface="Arial" pitchFamily="34" charset="0"/>
-                <a:cs typeface="Arial" pitchFamily="34" charset="0"/>
-              </a:rPr>
-              <a:t>decizie</a:t>
-            </a:r>
-            <a:r>
-              <a:rPr lang="ro-RO" sz="1600" b="1" dirty="0" smtClean="0">
-                <a:latin typeface="Arial" pitchFamily="34" charset="0"/>
-                <a:cs typeface="Arial" pitchFamily="34" charset="0"/>
-              </a:rPr>
-              <a:t>: </a:t>
-            </a:r>
-            <a:r>
-              <a:rPr lang="en-US" sz="1600" dirty="0" err="1">
-                <a:latin typeface="Arial" pitchFamily="34" charset="0"/>
-                <a:cs typeface="Arial" pitchFamily="34" charset="0"/>
-              </a:rPr>
-              <a:t>Fiecare</a:t>
-            </a:r>
-            <a:r>
-              <a:rPr lang="en-US" sz="1600" dirty="0">
-                <a:latin typeface="Arial" pitchFamily="34" charset="0"/>
-                <a:cs typeface="Arial" pitchFamily="34" charset="0"/>
-              </a:rPr>
-              <a:t> </a:t>
-            </a:r>
-            <a:r>
-              <a:rPr lang="en-US" sz="1600" b="1" dirty="0">
-                <a:latin typeface="Arial" pitchFamily="34" charset="0"/>
-                <a:cs typeface="Arial" pitchFamily="34" charset="0"/>
-              </a:rPr>
-              <a:t>if</a:t>
-            </a:r>
-            <a:r>
-              <a:rPr lang="en-US" sz="1600" dirty="0">
-                <a:latin typeface="Arial" pitchFamily="34" charset="0"/>
-                <a:cs typeface="Arial" pitchFamily="34" charset="0"/>
-              </a:rPr>
-              <a:t> </a:t>
-            </a:r>
-            <a:r>
-              <a:rPr lang="en-US" sz="1600" dirty="0" err="1">
-                <a:latin typeface="Arial" pitchFamily="34" charset="0"/>
-                <a:cs typeface="Arial" pitchFamily="34" charset="0"/>
-              </a:rPr>
-              <a:t>este</a:t>
-            </a:r>
-            <a:r>
-              <a:rPr lang="en-US" sz="1600" dirty="0">
-                <a:latin typeface="Arial" pitchFamily="34" charset="0"/>
-                <a:cs typeface="Arial" pitchFamily="34" charset="0"/>
-              </a:rPr>
-              <a:t> </a:t>
-            </a:r>
-            <a:r>
-              <a:rPr lang="en-US" sz="1600" dirty="0" err="1">
-                <a:latin typeface="Arial" pitchFamily="34" charset="0"/>
-                <a:cs typeface="Arial" pitchFamily="34" charset="0"/>
-              </a:rPr>
-              <a:t>executat</a:t>
-            </a:r>
-            <a:r>
-              <a:rPr lang="en-US" sz="1600" dirty="0">
-                <a:latin typeface="Arial" pitchFamily="34" charset="0"/>
-                <a:cs typeface="Arial" pitchFamily="34" charset="0"/>
-              </a:rPr>
-              <a:t> </a:t>
-            </a:r>
-            <a:endParaRPr lang="ro-RO" sz="1600" dirty="0" smtClean="0">
-              <a:latin typeface="Arial" pitchFamily="34" charset="0"/>
-              <a:cs typeface="Arial" pitchFamily="34" charset="0"/>
-            </a:endParaRPr>
-          </a:p>
-          <a:p>
-            <a:pPr marL="0" indent="0">
-              <a:buNone/>
-            </a:pPr>
-            <a:r>
-              <a:rPr lang="ro-RO" sz="1600" dirty="0" smtClean="0">
-                <a:latin typeface="Arial" pitchFamily="34" charset="0"/>
-                <a:cs typeface="Arial" pitchFamily="34" charset="0"/>
-              </a:rPr>
-              <a:t>      </a:t>
-            </a:r>
-            <a:r>
-              <a:rPr lang="en-US" sz="1600" dirty="0" err="1" smtClean="0">
-                <a:latin typeface="Arial" pitchFamily="34" charset="0"/>
-                <a:cs typeface="Arial" pitchFamily="34" charset="0"/>
-              </a:rPr>
-              <a:t>pe</a:t>
-            </a:r>
-            <a:r>
-              <a:rPr lang="en-US" sz="1600" dirty="0" smtClean="0">
-                <a:latin typeface="Arial" pitchFamily="34" charset="0"/>
-                <a:cs typeface="Arial" pitchFamily="34" charset="0"/>
-              </a:rPr>
-              <a:t> </a:t>
-            </a:r>
-            <a:r>
-              <a:rPr lang="en-US" sz="1600" dirty="0" err="1">
-                <a:latin typeface="Arial" pitchFamily="34" charset="0"/>
-                <a:cs typeface="Arial" pitchFamily="34" charset="0"/>
-              </a:rPr>
-              <a:t>ramura</a:t>
-            </a:r>
-            <a:r>
-              <a:rPr lang="en-US" sz="1600" dirty="0">
-                <a:latin typeface="Arial" pitchFamily="34" charset="0"/>
-                <a:cs typeface="Arial" pitchFamily="34" charset="0"/>
-              </a:rPr>
-              <a:t> </a:t>
-            </a:r>
-            <a:r>
-              <a:rPr lang="en-US" sz="1600" b="1" dirty="0">
-                <a:latin typeface="Arial" pitchFamily="34" charset="0"/>
-                <a:cs typeface="Arial" pitchFamily="34" charset="0"/>
-              </a:rPr>
-              <a:t>True</a:t>
-            </a:r>
-            <a:r>
-              <a:rPr lang="en-US" sz="1600" dirty="0">
-                <a:latin typeface="Arial" pitchFamily="34" charset="0"/>
-                <a:cs typeface="Arial" pitchFamily="34" charset="0"/>
-              </a:rPr>
-              <a:t> </a:t>
-            </a:r>
-            <a:r>
-              <a:rPr lang="en-US" sz="1600" dirty="0" err="1">
-                <a:latin typeface="Arial" pitchFamily="34" charset="0"/>
-                <a:cs typeface="Arial" pitchFamily="34" charset="0"/>
-              </a:rPr>
-              <a:t>și</a:t>
-            </a:r>
-            <a:r>
-              <a:rPr lang="en-US" sz="1600" dirty="0">
-                <a:latin typeface="Arial" pitchFamily="34" charset="0"/>
-                <a:cs typeface="Arial" pitchFamily="34" charset="0"/>
-              </a:rPr>
-              <a:t> </a:t>
-            </a:r>
-            <a:r>
-              <a:rPr lang="en-US" sz="1600" dirty="0" err="1">
-                <a:latin typeface="Arial" pitchFamily="34" charset="0"/>
-                <a:cs typeface="Arial" pitchFamily="34" charset="0"/>
-              </a:rPr>
-              <a:t>pe</a:t>
-            </a:r>
-            <a:r>
-              <a:rPr lang="en-US" sz="1600" dirty="0">
-                <a:latin typeface="Arial" pitchFamily="34" charset="0"/>
-                <a:cs typeface="Arial" pitchFamily="34" charset="0"/>
-              </a:rPr>
-              <a:t> </a:t>
-            </a:r>
-            <a:r>
-              <a:rPr lang="en-US" sz="1600" dirty="0" err="1">
-                <a:latin typeface="Arial" pitchFamily="34" charset="0"/>
-                <a:cs typeface="Arial" pitchFamily="34" charset="0"/>
-              </a:rPr>
-              <a:t>ramura</a:t>
-            </a:r>
-            <a:r>
-              <a:rPr lang="en-US" sz="1600" dirty="0">
-                <a:latin typeface="Arial" pitchFamily="34" charset="0"/>
-                <a:cs typeface="Arial" pitchFamily="34" charset="0"/>
-              </a:rPr>
-              <a:t> </a:t>
-            </a:r>
-            <a:r>
-              <a:rPr lang="en-US" sz="1600" b="1" dirty="0">
-                <a:latin typeface="Arial" pitchFamily="34" charset="0"/>
-                <a:cs typeface="Arial" pitchFamily="34" charset="0"/>
-              </a:rPr>
-              <a:t>False</a:t>
-            </a:r>
-            <a:r>
-              <a:rPr lang="en-US" sz="1600" dirty="0" smtClean="0">
-                <a:latin typeface="Arial" pitchFamily="34" charset="0"/>
-                <a:cs typeface="Arial" pitchFamily="34" charset="0"/>
-              </a:rPr>
-              <a:t>.</a:t>
-            </a:r>
-            <a:endParaRPr lang="ro-RO" sz="1600" dirty="0" smtClean="0">
-              <a:latin typeface="Arial" pitchFamily="34" charset="0"/>
-              <a:cs typeface="Arial" pitchFamily="34" charset="0"/>
-            </a:endParaRPr>
-          </a:p>
-          <a:p>
             <a:endParaRPr lang="ro-RO" sz="1600" dirty="0">
               <a:latin typeface="Arial" pitchFamily="34" charset="0"/>
               <a:cs typeface="Arial" pitchFamily="34" charset="0"/>
             </a:endParaRPr>
           </a:p>
           <a:p>
-            <a:endParaRPr lang="ro-RO" sz="1600" dirty="0" smtClean="0">
+            <a:r>
+              <a:rPr lang="en-US" sz="1600" b="1" dirty="0" err="1">
+                <a:latin typeface="Arial" pitchFamily="34" charset="0"/>
+                <a:cs typeface="Arial" pitchFamily="34" charset="0"/>
+              </a:rPr>
+              <a:t>Acoperire</a:t>
+            </a:r>
+            <a:r>
+              <a:rPr lang="en-US" sz="1600" b="1" dirty="0">
+                <a:latin typeface="Arial" pitchFamily="34" charset="0"/>
+                <a:cs typeface="Arial" pitchFamily="34" charset="0"/>
+              </a:rPr>
+              <a:t> </a:t>
+            </a:r>
+            <a:r>
+              <a:rPr lang="en-US" sz="1600" b="1" dirty="0" err="1">
+                <a:latin typeface="Arial" pitchFamily="34" charset="0"/>
+                <a:cs typeface="Arial" pitchFamily="34" charset="0"/>
+              </a:rPr>
+              <a:t>decizie</a:t>
+            </a:r>
+            <a:r>
+              <a:rPr lang="ro-RO" sz="1600" b="1" dirty="0">
+                <a:latin typeface="Arial" pitchFamily="34" charset="0"/>
+                <a:cs typeface="Arial" pitchFamily="34" charset="0"/>
+              </a:rPr>
+              <a:t>: </a:t>
+            </a:r>
+            <a:r>
+              <a:rPr lang="en-US" sz="1600" dirty="0" err="1">
+                <a:latin typeface="Arial" pitchFamily="34" charset="0"/>
+                <a:cs typeface="Arial" pitchFamily="34" charset="0"/>
+              </a:rPr>
+              <a:t>Fiecare</a:t>
+            </a:r>
+            <a:r>
+              <a:rPr lang="en-US" sz="1600" dirty="0">
+                <a:latin typeface="Arial" pitchFamily="34" charset="0"/>
+                <a:cs typeface="Arial" pitchFamily="34" charset="0"/>
+              </a:rPr>
+              <a:t> </a:t>
+            </a:r>
+            <a:r>
+              <a:rPr lang="en-US" sz="1600" b="1" dirty="0">
+                <a:latin typeface="Arial" pitchFamily="34" charset="0"/>
+                <a:cs typeface="Arial" pitchFamily="34" charset="0"/>
+              </a:rPr>
+              <a:t>if</a:t>
+            </a:r>
+            <a:r>
+              <a:rPr lang="en-US" sz="1600" dirty="0">
+                <a:latin typeface="Arial" pitchFamily="34" charset="0"/>
+                <a:cs typeface="Arial" pitchFamily="34" charset="0"/>
+              </a:rPr>
+              <a:t> </a:t>
+            </a:r>
+            <a:r>
+              <a:rPr lang="en-US" sz="1600" dirty="0" err="1">
+                <a:latin typeface="Arial" pitchFamily="34" charset="0"/>
+                <a:cs typeface="Arial" pitchFamily="34" charset="0"/>
+              </a:rPr>
+              <a:t>este</a:t>
+            </a:r>
+            <a:r>
+              <a:rPr lang="en-US" sz="1600" dirty="0">
+                <a:latin typeface="Arial" pitchFamily="34" charset="0"/>
+                <a:cs typeface="Arial" pitchFamily="34" charset="0"/>
+              </a:rPr>
+              <a:t> </a:t>
+            </a:r>
+            <a:r>
+              <a:rPr lang="en-US" sz="1600" dirty="0" err="1">
+                <a:latin typeface="Arial" pitchFamily="34" charset="0"/>
+                <a:cs typeface="Arial" pitchFamily="34" charset="0"/>
+              </a:rPr>
+              <a:t>executat</a:t>
+            </a:r>
+            <a:r>
+              <a:rPr lang="en-US" sz="1600" dirty="0">
+                <a:latin typeface="Arial" pitchFamily="34" charset="0"/>
+                <a:cs typeface="Arial" pitchFamily="34" charset="0"/>
+              </a:rPr>
+              <a:t> </a:t>
+            </a:r>
+            <a:endParaRPr lang="ro-RO" sz="1600" dirty="0">
               <a:latin typeface="Arial" pitchFamily="34" charset="0"/>
               <a:cs typeface="Arial" pitchFamily="34" charset="0"/>
             </a:endParaRPr>
@@ -9061,85 +8788,197 @@
             <a:pPr marL="0" indent="0">
               <a:buNone/>
             </a:pPr>
-            <a:endParaRPr lang="ro-RO" sz="1600" dirty="0" smtClean="0">
+            <a:r>
+              <a:rPr lang="ro-RO" sz="1600" dirty="0">
+                <a:latin typeface="Arial" pitchFamily="34" charset="0"/>
+                <a:cs typeface="Arial" pitchFamily="34" charset="0"/>
+              </a:rPr>
+              <a:t>      </a:t>
+            </a:r>
+            <a:r>
+              <a:rPr lang="en-US" sz="1600" dirty="0" err="1">
+                <a:latin typeface="Arial" pitchFamily="34" charset="0"/>
+                <a:cs typeface="Arial" pitchFamily="34" charset="0"/>
+              </a:rPr>
+              <a:t>pe</a:t>
+            </a:r>
+            <a:r>
+              <a:rPr lang="en-US" sz="1600" dirty="0">
+                <a:latin typeface="Arial" pitchFamily="34" charset="0"/>
+                <a:cs typeface="Arial" pitchFamily="34" charset="0"/>
+              </a:rPr>
+              <a:t> </a:t>
+            </a:r>
+            <a:r>
+              <a:rPr lang="en-US" sz="1600" dirty="0" err="1">
+                <a:latin typeface="Arial" pitchFamily="34" charset="0"/>
+                <a:cs typeface="Arial" pitchFamily="34" charset="0"/>
+              </a:rPr>
+              <a:t>ramura</a:t>
+            </a:r>
+            <a:r>
+              <a:rPr lang="en-US" sz="1600" dirty="0">
+                <a:latin typeface="Arial" pitchFamily="34" charset="0"/>
+                <a:cs typeface="Arial" pitchFamily="34" charset="0"/>
+              </a:rPr>
+              <a:t> </a:t>
+            </a:r>
+            <a:r>
+              <a:rPr lang="en-US" sz="1600" b="1" dirty="0">
+                <a:latin typeface="Arial" pitchFamily="34" charset="0"/>
+                <a:cs typeface="Arial" pitchFamily="34" charset="0"/>
+              </a:rPr>
+              <a:t>True</a:t>
+            </a:r>
+            <a:r>
+              <a:rPr lang="en-US" sz="1600" dirty="0">
+                <a:latin typeface="Arial" pitchFamily="34" charset="0"/>
+                <a:cs typeface="Arial" pitchFamily="34" charset="0"/>
+              </a:rPr>
+              <a:t> </a:t>
+            </a:r>
+            <a:r>
+              <a:rPr lang="en-US" sz="1600" dirty="0" err="1">
+                <a:latin typeface="Arial" pitchFamily="34" charset="0"/>
+                <a:cs typeface="Arial" pitchFamily="34" charset="0"/>
+              </a:rPr>
+              <a:t>și</a:t>
+            </a:r>
+            <a:r>
+              <a:rPr lang="en-US" sz="1600" dirty="0">
+                <a:latin typeface="Arial" pitchFamily="34" charset="0"/>
+                <a:cs typeface="Arial" pitchFamily="34" charset="0"/>
+              </a:rPr>
+              <a:t> </a:t>
+            </a:r>
+            <a:r>
+              <a:rPr lang="en-US" sz="1600" dirty="0" err="1">
+                <a:latin typeface="Arial" pitchFamily="34" charset="0"/>
+                <a:cs typeface="Arial" pitchFamily="34" charset="0"/>
+              </a:rPr>
+              <a:t>pe</a:t>
+            </a:r>
+            <a:r>
+              <a:rPr lang="en-US" sz="1600" dirty="0">
+                <a:latin typeface="Arial" pitchFamily="34" charset="0"/>
+                <a:cs typeface="Arial" pitchFamily="34" charset="0"/>
+              </a:rPr>
+              <a:t> </a:t>
+            </a:r>
+            <a:r>
+              <a:rPr lang="en-US" sz="1600" dirty="0" err="1">
+                <a:latin typeface="Arial" pitchFamily="34" charset="0"/>
+                <a:cs typeface="Arial" pitchFamily="34" charset="0"/>
+              </a:rPr>
+              <a:t>ramura</a:t>
+            </a:r>
+            <a:r>
+              <a:rPr lang="en-US" sz="1600" dirty="0">
+                <a:latin typeface="Arial" pitchFamily="34" charset="0"/>
+                <a:cs typeface="Arial" pitchFamily="34" charset="0"/>
+              </a:rPr>
+              <a:t> </a:t>
+            </a:r>
+            <a:r>
+              <a:rPr lang="en-US" sz="1600" b="1" dirty="0">
+                <a:latin typeface="Arial" pitchFamily="34" charset="0"/>
+                <a:cs typeface="Arial" pitchFamily="34" charset="0"/>
+              </a:rPr>
+              <a:t>False</a:t>
+            </a:r>
+            <a:r>
+              <a:rPr lang="en-US" sz="1600" dirty="0">
+                <a:latin typeface="Arial" pitchFamily="34" charset="0"/>
+                <a:cs typeface="Arial" pitchFamily="34" charset="0"/>
+              </a:rPr>
+              <a:t>.</a:t>
+            </a:r>
+            <a:endParaRPr lang="ro-RO" sz="1600" dirty="0">
               <a:latin typeface="Arial" pitchFamily="34" charset="0"/>
               <a:cs typeface="Arial" pitchFamily="34" charset="0"/>
             </a:endParaRPr>
           </a:p>
           <a:p>
-            <a:r>
-              <a:rPr lang="en-US" sz="1600" b="1" dirty="0" err="1">
-                <a:latin typeface="Arial" pitchFamily="34" charset="0"/>
-                <a:cs typeface="Arial" pitchFamily="34" charset="0"/>
-              </a:rPr>
-              <a:t>Acoperire</a:t>
-            </a:r>
-            <a:r>
-              <a:rPr lang="en-US" sz="1600" b="1" dirty="0">
-                <a:latin typeface="Arial" pitchFamily="34" charset="0"/>
-                <a:cs typeface="Arial" pitchFamily="34" charset="0"/>
-              </a:rPr>
-              <a:t> </a:t>
-            </a:r>
-            <a:r>
-              <a:rPr lang="en-US" sz="1600" b="1" dirty="0" err="1" smtClean="0">
-                <a:latin typeface="Arial" pitchFamily="34" charset="0"/>
-                <a:cs typeface="Arial" pitchFamily="34" charset="0"/>
-              </a:rPr>
-              <a:t>condiție</a:t>
-            </a:r>
-            <a:r>
-              <a:rPr lang="ro-RO" sz="1600" b="1" dirty="0" smtClean="0">
-                <a:latin typeface="Arial" pitchFamily="34" charset="0"/>
-                <a:cs typeface="Arial" pitchFamily="34" charset="0"/>
-              </a:rPr>
-              <a:t>: </a:t>
-            </a:r>
-            <a:r>
-              <a:rPr lang="vi-VN" sz="1600" dirty="0">
-                <a:latin typeface="Arial" pitchFamily="34" charset="0"/>
-                <a:cs typeface="Arial" pitchFamily="34" charset="0"/>
-              </a:rPr>
-              <a:t>Fiecare condiție atomică dintr-o </a:t>
-            </a:r>
-            <a:endParaRPr lang="ro-RO" sz="1600" dirty="0" smtClean="0">
+            <a:endParaRPr lang="ro-RO" sz="1600" dirty="0">
               <a:latin typeface="Arial" pitchFamily="34" charset="0"/>
               <a:cs typeface="Arial" pitchFamily="34" charset="0"/>
             </a:endParaRPr>
           </a:p>
           <a:p>
+            <a:endParaRPr lang="ro-RO" sz="1600" dirty="0">
+              <a:latin typeface="Arial" pitchFamily="34" charset="0"/>
+              <a:cs typeface="Arial" pitchFamily="34" charset="0"/>
+            </a:endParaRPr>
+          </a:p>
+          <a:p>
             <a:pPr marL="0" indent="0">
               <a:buNone/>
             </a:pPr>
-            <a:r>
-              <a:rPr lang="ro-RO" sz="1600" dirty="0" smtClean="0">
+            <a:endParaRPr lang="ro-RO" sz="1600" dirty="0">
+              <a:latin typeface="Arial" pitchFamily="34" charset="0"/>
+              <a:cs typeface="Arial" pitchFamily="34" charset="0"/>
+            </a:endParaRPr>
+          </a:p>
+          <a:p>
+            <a:r>
+              <a:rPr lang="en-US" sz="1600" b="1" dirty="0" err="1">
+                <a:latin typeface="Arial" pitchFamily="34" charset="0"/>
+                <a:cs typeface="Arial" pitchFamily="34" charset="0"/>
+              </a:rPr>
+              <a:t>Acoperire</a:t>
+            </a:r>
+            <a:r>
+              <a:rPr lang="en-US" sz="1600" b="1" dirty="0">
+                <a:latin typeface="Arial" pitchFamily="34" charset="0"/>
+                <a:cs typeface="Arial" pitchFamily="34" charset="0"/>
+              </a:rPr>
+              <a:t> </a:t>
+            </a:r>
+            <a:r>
+              <a:rPr lang="en-US" sz="1600" b="1" dirty="0" err="1">
+                <a:latin typeface="Arial" pitchFamily="34" charset="0"/>
+                <a:cs typeface="Arial" pitchFamily="34" charset="0"/>
+              </a:rPr>
+              <a:t>condiție</a:t>
+            </a:r>
+            <a:r>
+              <a:rPr lang="ro-RO" sz="1600" b="1" dirty="0">
+                <a:latin typeface="Arial" pitchFamily="34" charset="0"/>
+                <a:cs typeface="Arial" pitchFamily="34" charset="0"/>
+              </a:rPr>
+              <a:t>: </a:t>
+            </a:r>
+            <a:r>
+              <a:rPr lang="vi-VN" sz="1600" dirty="0">
+                <a:latin typeface="Arial" pitchFamily="34" charset="0"/>
+                <a:cs typeface="Arial" pitchFamily="34" charset="0"/>
+              </a:rPr>
+              <a:t>Fiecare condiție atomică dintr-o </a:t>
+            </a:r>
+            <a:endParaRPr lang="ro-RO" sz="1600" dirty="0">
+              <a:latin typeface="Arial" pitchFamily="34" charset="0"/>
+              <a:cs typeface="Arial" pitchFamily="34" charset="0"/>
+            </a:endParaRPr>
+          </a:p>
+          <a:p>
+            <a:pPr marL="0" indent="0">
+              <a:buNone/>
+            </a:pPr>
+            <a:r>
+              <a:rPr lang="ro-RO" sz="1600" dirty="0">
                 <a:latin typeface="Arial" pitchFamily="34" charset="0"/>
                 <a:cs typeface="Arial" pitchFamily="34" charset="0"/>
               </a:rPr>
               <a:t>      </a:t>
             </a:r>
             <a:r>
-              <a:rPr lang="vi-VN" sz="1600" dirty="0" smtClean="0">
-                <a:latin typeface="Arial" pitchFamily="34" charset="0"/>
-                <a:cs typeface="Arial" pitchFamily="34" charset="0"/>
-              </a:rPr>
-              <a:t>expresie </a:t>
-            </a:r>
-            <a:r>
               <a:rPr lang="vi-VN" sz="1600" dirty="0">
                 <a:latin typeface="Arial" pitchFamily="34" charset="0"/>
                 <a:cs typeface="Arial" pitchFamily="34" charset="0"/>
               </a:rPr>
-              <a:t>compusă este testată independent</a:t>
-            </a:r>
-            <a:r>
-              <a:rPr lang="vi-VN" sz="1600" dirty="0" smtClean="0">
-                <a:latin typeface="Arial" pitchFamily="34" charset="0"/>
-                <a:cs typeface="Arial" pitchFamily="34" charset="0"/>
-              </a:rPr>
-              <a:t>.</a:t>
-            </a:r>
-            <a:endParaRPr lang="ro-RO" sz="1600" dirty="0" smtClean="0">
+              <a:t>expresie compusă este testată independent.</a:t>
+            </a:r>
+            <a:endParaRPr lang="ro-RO" sz="1600" dirty="0">
               <a:latin typeface="Arial" pitchFamily="34" charset="0"/>
               <a:cs typeface="Arial" pitchFamily="34" charset="0"/>
             </a:endParaRPr>
@@ -9415,11 +9254,11 @@
               <a:t> </a:t>
             </a:r>
             <a:r>
-              <a:rPr lang="en-US" b="1" dirty="0" err="1" smtClean="0"/>
+              <a:rPr lang="en-US" b="1" dirty="0" err="1"/>
               <a:t>diagrame</a:t>
             </a:r>
             <a:r>
-              <a:rPr lang="ro-RO" b="1" dirty="0" smtClean="0"/>
+              <a:rPr lang="ro-RO" b="1" dirty="0"/>
               <a:t> – 10 drumuri</a:t>
             </a:r>
             <a:endParaRPr lang="en-US" dirty="0"/>
@@ -9691,70 +9530,6 @@
           </a:extLst>
         </p:spPr>
       </p:pic>
-      <p:pic>
-        <p:nvPicPr>
-          <p:cNvPr id="8197" name="Picture 5"/>
-          <p:cNvPicPr>
-            <a:picLocks noChangeAspect="1" noChangeArrowheads="1"/>
-          </p:cNvPicPr>
-          <p:nvPr/>
-        </p:nvPicPr>
-        <p:blipFill>
-          <a:blip r:embed="rId5">
-            <a:extLst>
-              <a:ext uri="{28A0092B-C50C-407E-A947-70E740481C1C}">
-                <a14:useLocalDpi xmlns:a14="http://schemas.microsoft.com/office/drawing/2010/main" val="0"/>
-              </a:ext>
-            </a:extLst>
-          </a:blip>
-          <a:srcRect/>
-          <a:stretch>
-            <a:fillRect/>
-          </a:stretch>
-        </p:blipFill>
-        <p:spPr bwMode="auto">
-          <a:xfrm>
-            <a:off x="266701" y="4250485"/>
-            <a:ext cx="4038600" cy="2607515"/>
-          </a:xfrm>
-          <a:prstGeom prst="rect">
-            <a:avLst/>
-          </a:prstGeom>
-          <a:noFill/>
-          <a:ln>
-            <a:noFill/>
-          </a:ln>
-          <a:effectLst/>
-          <a:extLst>
-            <a:ext uri="{909E8E84-426E-40DD-AFC4-6F175D3DCCD1}">
-              <a14:hiddenFill xmlns:a14="http://schemas.microsoft.com/office/drawing/2010/main">
-                <a:solidFill>
-                  <a:schemeClr val="accent1"/>
-                </a:solidFill>
-              </a14:hiddenFill>
-            </a:ext>
-            <a:ext uri="{91240B29-F687-4F45-9708-019B960494DF}">
-              <a14:hiddenLine xmlns:a14="http://schemas.microsoft.com/office/drawing/2010/main" w="9525">
-                <a:solidFill>
-                  <a:schemeClr val="tx1"/>
-                </a:solidFill>
-                <a:miter lim="800000"/>
-                <a:headEnd/>
-                <a:tailEnd/>
-              </a14:hiddenLine>
-            </a:ext>
-            <a:ext uri="{AF507438-7753-43E0-B8FC-AC1667EBCBE1}">
-              <a14:hiddenEffects xmlns:a14="http://schemas.microsoft.com/office/drawing/2010/main">
-                <a:effectLst>
-                  <a:outerShdw dist="35921" dir="2700000" algn="ctr" rotWithShape="0">
-                    <a:schemeClr val="bg2"/>
-                  </a:outerShdw>
-                </a:effectLst>
-              </a14:hiddenEffects>
-            </a:ext>
-          </a:extLst>
-        </p:spPr>
-      </p:pic>
       <p:sp>
         <p:nvSpPr>
           <p:cNvPr id="10" name="Rectangle 9"/>
@@ -9777,13 +9552,43 @@
           <a:lstStyle/>
           <a:p>
             <a:r>
-              <a:rPr lang="ro-RO" b="1" dirty="0" smtClean="0"/>
+              <a:rPr lang="ro-RO" b="1" dirty="0"/>
               <a:t>Diagramele pot fi văzute în README.md</a:t>
             </a:r>
             <a:endParaRPr lang="en-US" b="1" dirty="0"/>
           </a:p>
         </p:txBody>
       </p:sp>
+      <p:pic>
+        <p:nvPicPr>
+          <p:cNvPr id="6" name="Picture 5">
+            <a:extLst>
+              <a:ext uri="{FF2B5EF4-FFF2-40B4-BE49-F238E27FC236}">
+                <a16:creationId xmlns:a16="http://schemas.microsoft.com/office/drawing/2014/main" id="{58406CC1-0139-9AAF-059A-FE9A0A4C6F93}"/>
+              </a:ext>
+            </a:extLst>
+          </p:cNvPr>
+          <p:cNvPicPr>
+            <a:picLocks noChangeAspect="1"/>
+          </p:cNvPicPr>
+          <p:nvPr/>
+        </p:nvPicPr>
+        <p:blipFill>
+          <a:blip r:embed="rId5"/>
+          <a:stretch>
+            <a:fillRect/>
+          </a:stretch>
+        </p:blipFill>
+        <p:spPr>
+          <a:xfrm>
+            <a:off x="361741" y="4188558"/>
+            <a:ext cx="4175918" cy="2669442"/>
+          </a:xfrm>
+          <a:prstGeom prst="rect">
+            <a:avLst/>
+          </a:prstGeom>
+        </p:spPr>
+      </p:pic>
     </p:spTree>
     <p:extLst>
       <p:ext uri="{BB962C8B-B14F-4D97-AF65-F5344CB8AC3E}">
@@ -9841,15 +9646,11 @@
               <a:t>Mutation Testing: </a:t>
             </a:r>
             <a:r>
-              <a:rPr lang="en-US" sz="2000" b="1" dirty="0" err="1" smtClean="0"/>
+              <a:rPr lang="en-US" sz="2000" b="1" dirty="0" err="1"/>
               <a:t>mutmut</a:t>
             </a:r>
-            <a:r>
-              <a:rPr lang="ro-RO" sz="2000" b="1" dirty="0" smtClean="0"/>
-              <a:t/>
-            </a:r>
             <a:br>
-              <a:rPr lang="ro-RO" sz="2000" b="1" dirty="0" smtClean="0"/>
+              <a:rPr lang="ro-RO" sz="2000" b="1" dirty="0"/>
             </a:br>
             <a:r>
               <a:rPr lang="vi-VN" sz="2000" dirty="0"/>
@@ -9895,14 +9696,10 @@
             </a:r>
             <a:r>
               <a:rPr lang="en-US" b="1" i="1" dirty="0"/>
-              <a:t> mutation testing</a:t>
-            </a:r>
-            <a:r>
-              <a:rPr lang="en-US" b="1" i="1" dirty="0" smtClean="0"/>
-              <a:t>?</a:t>
-            </a:r>
-            <a:r>
-              <a:rPr lang="ro-RO" i="1" dirty="0" smtClean="0"/>
+              <a:t> mutation testing?</a:t>
+            </a:r>
+            <a:r>
+              <a:rPr lang="ro-RO" i="1" dirty="0"/>
               <a:t> </a:t>
             </a:r>
             <a:r>
@@ -9923,13 +9720,9 @@
             </a:r>
             <a:r>
               <a:rPr lang="vi-VN" dirty="0"/>
-              <a:t> = niciun test nu a sesizat modificarea</a:t>
-            </a:r>
-            <a:r>
-              <a:rPr lang="vi-VN" dirty="0" smtClean="0"/>
-              <a:t>.</a:t>
-            </a:r>
-            <a:endParaRPr lang="ro-RO" dirty="0" smtClean="0"/>
+              <a:t> = niciun test nu a sesizat modificarea.</a:t>
+            </a:r>
+            <a:endParaRPr lang="ro-RO" dirty="0"/>
           </a:p>
           <a:p>
             <a:r>
@@ -9950,13 +9743,13 @@
             </a:r>
           </a:p>
           <a:p>
-            <a:endParaRPr lang="ro-RO" b="1" dirty="0" smtClean="0"/>
+            <a:endParaRPr lang="ro-RO" b="1" dirty="0"/>
           </a:p>
           <a:p>
             <a:pPr marL="0" indent="0">
               <a:buNone/>
             </a:pPr>
-            <a:endParaRPr lang="ro-RO" b="1" dirty="0" smtClean="0"/>
+            <a:endParaRPr lang="ro-RO" b="1" dirty="0"/>
           </a:p>
           <a:p>
             <a:r>
@@ -9965,25 +9758,17 @@
             </a:r>
             <a:r>
               <a:rPr lang="vi-VN" dirty="0"/>
-              <a:t> Categoria </a:t>
-            </a:r>
-            <a:r>
-              <a:rPr lang="vi-VN" dirty="0"/>
-              <a:t>Suspicious</a:t>
-            </a:r>
-            <a:r>
-              <a:rPr lang="vi-VN" dirty="0"/>
-              <a:t> înseamnă că rularea unui test a durat mai mult decât baseline-ul, fără timeout fatal. Rezultatul important este </a:t>
+              <a:t> Categoria Suspicious înseamnă că rularea unui test a durat mai mult decât baseline-ul, fără timeout fatal. Rezultatul important este </a:t>
             </a:r>
             <a:r>
               <a:rPr lang="vi-VN" b="1" dirty="0"/>
               <a:t>0 survived</a:t>
             </a:r>
             <a:r>
-              <a:rPr lang="vi-VN" dirty="0" smtClean="0"/>
+              <a:rPr lang="vi-VN" dirty="0"/>
               <a:t>.</a:t>
             </a:r>
-            <a:endParaRPr lang="ro-RO" dirty="0" smtClean="0"/>
+            <a:endParaRPr lang="ro-RO" dirty="0"/>
           </a:p>
           <a:p>
             <a:r>
@@ -10435,7 +10220,7 @@
   <a:extraClrSchemeLst/>
   <a:extLst>
     <a:ext uri="{05A4C25C-085E-4340-85A3-A5531E510DB2}">
-      <thm15:themeFamily xmlns:thm15="http://schemas.microsoft.com/office/thememl/2012/main" xmlns="" name="DividendVTI" id="{97558BDE-0B66-457C-BB6F-7B1B22DAA9B8}" vid="{F53508A3-AC60-448A-AF37-934D5F1A0D5E}"/>
+      <thm15:themeFamily xmlns:thm15="http://schemas.microsoft.com/office/thememl/2012/main" name="DividendVTI" id="{97558BDE-0B66-457C-BB6F-7B1B22DAA9B8}" vid="{F53508A3-AC60-448A-AF37-934D5F1A0D5E}"/>
     </a:ext>
   </a:extLst>
 </a:theme>

</xml_diff>